<commit_message>
Redesign Week1 Thursday deck: fake-it-then-make-it project day (WoZ, double diamond, partial-WoZ with AI, DIS'25 co-design)
Co-Authored-By: Claude Fable 5 <noreply@anthropic.com>
</commit_message>
<xml_diff>
--- a/slides/Week1-Thu-Project-Day.pptx
+++ b/slides/Week1-Thu-Project-Day.pptx
@@ -7,6 +7,16 @@
   <p:sldIdLst>
     <p:sldId id="256" r:id="rId7"/>
     <p:sldId id="257" r:id="rId8"/>
+    <p:sldId id="258" r:id="rId10"/>
+    <p:sldId id="259" r:id="rId11"/>
+    <p:sldId id="260" r:id="rId12"/>
+    <p:sldId id="261" r:id="rId13"/>
+    <p:sldId id="262" r:id="rId14"/>
+    <p:sldId id="263" r:id="rId15"/>
+    <p:sldId id="264" r:id="rId16"/>
+    <p:sldId id="265" r:id="rId17"/>
+    <p:sldId id="266" r:id="rId18"/>
+    <p:sldId id="267" r:id="rId19"/>
   </p:sldIdLst>
   <p:sldSz cx="12191695" cy="6858000" type="screen4x3"/>
   <p:notesSz cx="6858000" cy="9144000"/>
@@ -503,7 +513,427 @@
           <a:lstStyle/>
           <a:p>
             <a:r>
-              <a:t>Enriched the empty 'Project Day' slide with the Project 1 brief essentials from the repo. Group projects are separate Classroom team repos (confirm details with Jonathan).</a:t>
+              <a:t>Project 1 brief essentials. The team repo comes pre-seeded: code_deliverable/, log_deliverable/, project-report.md template, Vibe-Trace configs, Pages deploy workflow.</a:t>
+            </a:r>
+          </a:p>
+        </p:txBody>
+      </p:sp>
+      <p:sp>
+        <p:nvSpPr>
+          <p:cNvPr id="4" name="Slide Number Placeholder 3"/>
+          <p:cNvSpPr>
+            <a:spLocks noGrp="1"/>
+          </p:cNvSpPr>
+          <p:nvPr>
+            <p:ph type="sldNum" idx="5" sz="quarter"/>
+          </p:nvPr>
+        </p:nvSpPr>
+        <p:spPr/>
+      </p:sp>
+    </p:spTree>
+  </p:cSld>
+  <p:clrMapOvr>
+    <a:masterClrMapping/>
+  </p:clrMapOvr>
+</p:notes>
+</file>
+
+<file path=ppt/notesSlides/notesSlide2.xml><?xml version="1.0" encoding="utf-8"?>
+<p:notes xmlns:a="http://schemas.openxmlformats.org/drawingml/2006/main" xmlns:p="http://schemas.openxmlformats.org/presentationml/2006/main" xmlns:r="http://schemas.openxmlformats.org/officeDocument/2006/relationships">
+  <p:cSld>
+    <p:spTree>
+      <p:nvGrpSpPr>
+        <p:cNvPr id="1" name=""/>
+        <p:cNvGrpSpPr/>
+        <p:nvPr/>
+      </p:nvGrpSpPr>
+      <p:grpSpPr>
+        <a:xfrm>
+          <a:off x="0" y="0"/>
+          <a:ext cx="0" cy="0"/>
+          <a:chOff x="0" y="0"/>
+          <a:chExt cx="0" cy="0"/>
+        </a:xfrm>
+      </p:grpSpPr>
+      <p:sp>
+        <p:nvSpPr>
+          <p:cNvPr id="2" name="Slide Image Placeholder 1"/>
+          <p:cNvSpPr>
+            <a:spLocks noGrp="1"/>
+          </p:cNvSpPr>
+          <p:nvPr>
+            <p:ph type="sldImg" idx="2"/>
+          </p:nvPr>
+        </p:nvSpPr>
+        <p:spPr/>
+      </p:sp>
+      <p:sp>
+        <p:nvSpPr>
+          <p:cNvPr id="3" name="Notes Placeholder 2"/>
+          <p:cNvSpPr>
+            <a:spLocks noGrp="1"/>
+          </p:cNvSpPr>
+          <p:nvPr>
+            <p:ph type="body" idx="3" sz="quarter"/>
+          </p:nvPr>
+        </p:nvSpPr>
+        <p:spPr/>
+        <p:txBody>
+          <a:bodyPr/>
+          <a:lstStyle/>
+          <a:p>
+            <a:r>
+              <a:t>Motivation beat. Vibe coding makes building cheap — which makes building the WRONG thing the biggest remaining waste. Today's method spends 30 minutes of theater to save days of misdirected code.</a:t>
+            </a:r>
+          </a:p>
+        </p:txBody>
+      </p:sp>
+      <p:sp>
+        <p:nvSpPr>
+          <p:cNvPr id="4" name="Slide Number Placeholder 3"/>
+          <p:cNvSpPr>
+            <a:spLocks noGrp="1"/>
+          </p:cNvSpPr>
+          <p:nvPr>
+            <p:ph type="sldNum" idx="5" sz="quarter"/>
+          </p:nvPr>
+        </p:nvSpPr>
+        <p:spPr/>
+      </p:sp>
+    </p:spTree>
+  </p:cSld>
+  <p:clrMapOvr>
+    <a:masterClrMapping/>
+  </p:clrMapOvr>
+</p:notes>
+</file>
+
+<file path=ppt/notesSlides/notesSlide3.xml><?xml version="1.0" encoding="utf-8"?>
+<p:notes xmlns:a="http://schemas.openxmlformats.org/drawingml/2006/main" xmlns:p="http://schemas.openxmlformats.org/presentationml/2006/main" xmlns:r="http://schemas.openxmlformats.org/officeDocument/2006/relationships">
+  <p:cSld>
+    <p:spTree>
+      <p:nvGrpSpPr>
+        <p:cNvPr id="1" name=""/>
+        <p:cNvGrpSpPr/>
+        <p:nvPr/>
+      </p:nvGrpSpPr>
+      <p:grpSpPr>
+        <a:xfrm>
+          <a:off x="0" y="0"/>
+          <a:ext cx="0" cy="0"/>
+          <a:chOff x="0" y="0"/>
+          <a:chExt cx="0" cy="0"/>
+        </a:xfrm>
+      </p:grpSpPr>
+      <p:sp>
+        <p:nvSpPr>
+          <p:cNvPr id="2" name="Slide Image Placeholder 1"/>
+          <p:cNvSpPr>
+            <a:spLocks noGrp="1"/>
+          </p:cNvSpPr>
+          <p:nvPr>
+            <p:ph type="sldImg" idx="2"/>
+          </p:nvPr>
+        </p:nvSpPr>
+        <p:spPr/>
+      </p:sp>
+      <p:sp>
+        <p:nvSpPr>
+          <p:cNvPr id="3" name="Notes Placeholder 2"/>
+          <p:cNvSpPr>
+            <a:spLocks noGrp="1"/>
+          </p:cNvSpPr>
+          <p:nvPr>
+            <p:ph type="body" idx="3" sz="quarter"/>
+          </p:nvPr>
+        </p:nvSpPr>
+        <p:spPr/>
+        <p:txBody>
+          <a:bodyPr/>
+          <a:lstStyle/>
+          <a:p>
+            <a:r>
+              <a:t>Double Diamond (UK Design Council). Map to today: Discover = team brainstorm; Define = pick one + the in-class fake-it test + redefinition; Develop = co-design options with the AI; Deliver = the focused build, hosted by Monday.</a:t>
+            </a:r>
+          </a:p>
+        </p:txBody>
+      </p:sp>
+      <p:sp>
+        <p:nvSpPr>
+          <p:cNvPr id="4" name="Slide Number Placeholder 3"/>
+          <p:cNvSpPr>
+            <a:spLocks noGrp="1"/>
+          </p:cNvSpPr>
+          <p:nvPr>
+            <p:ph type="sldNum" idx="5" sz="quarter"/>
+          </p:nvPr>
+        </p:nvSpPr>
+        <p:spPr/>
+      </p:sp>
+    </p:spTree>
+  </p:cSld>
+  <p:clrMapOvr>
+    <a:masterClrMapping/>
+  </p:clrMapOvr>
+</p:notes>
+</file>
+
+<file path=ppt/notesSlides/notesSlide4.xml><?xml version="1.0" encoding="utf-8"?>
+<p:notes xmlns:a="http://schemas.openxmlformats.org/drawingml/2006/main" xmlns:p="http://schemas.openxmlformats.org/presentationml/2006/main" xmlns:r="http://schemas.openxmlformats.org/officeDocument/2006/relationships">
+  <p:cSld>
+    <p:spTree>
+      <p:nvGrpSpPr>
+        <p:cNvPr id="1" name=""/>
+        <p:cNvGrpSpPr/>
+        <p:nvPr/>
+      </p:nvGrpSpPr>
+      <p:grpSpPr>
+        <a:xfrm>
+          <a:off x="0" y="0"/>
+          <a:ext cx="0" cy="0"/>
+          <a:chOff x="0" y="0"/>
+          <a:chExt cx="0" cy="0"/>
+        </a:xfrm>
+      </p:grpSpPr>
+      <p:sp>
+        <p:nvSpPr>
+          <p:cNvPr id="2" name="Slide Image Placeholder 1"/>
+          <p:cNvSpPr>
+            <a:spLocks noGrp="1"/>
+          </p:cNvSpPr>
+          <p:nvPr>
+            <p:ph type="sldImg" idx="2"/>
+          </p:nvPr>
+        </p:nvSpPr>
+        <p:spPr/>
+      </p:sp>
+      <p:sp>
+        <p:nvSpPr>
+          <p:cNvPr id="3" name="Notes Placeholder 2"/>
+          <p:cNvSpPr>
+            <a:spLocks noGrp="1"/>
+          </p:cNvSpPr>
+          <p:nvPr>
+            <p:ph type="body" idx="3" sz="quarter"/>
+          </p:nvPr>
+        </p:nvSpPr>
+        <p:spPr/>
+        <p:txBody>
+          <a:bodyPr/>
+          <a:lstStyle/>
+          <a:p>
+            <a:r>
+              <a:t>Origin: J.F. Kelley's 'listening typewriter' experiments at IBM (1983–84) coined the term. Keep it light — the man-behind-the-curtain image carries the idea.</a:t>
+            </a:r>
+          </a:p>
+        </p:txBody>
+      </p:sp>
+      <p:sp>
+        <p:nvSpPr>
+          <p:cNvPr id="4" name="Slide Number Placeholder 3"/>
+          <p:cNvSpPr>
+            <a:spLocks noGrp="1"/>
+          </p:cNvSpPr>
+          <p:nvPr>
+            <p:ph type="sldNum" idx="5" sz="quarter"/>
+          </p:nvPr>
+        </p:nvSpPr>
+        <p:spPr/>
+      </p:sp>
+    </p:spTree>
+  </p:cSld>
+  <p:clrMapOvr>
+    <a:masterClrMapping/>
+  </p:clrMapOvr>
+</p:notes>
+</file>
+
+<file path=ppt/notesSlides/notesSlide5.xml><?xml version="1.0" encoding="utf-8"?>
+<p:notes xmlns:a="http://schemas.openxmlformats.org/drawingml/2006/main" xmlns:p="http://schemas.openxmlformats.org/presentationml/2006/main" xmlns:r="http://schemas.openxmlformats.org/officeDocument/2006/relationships">
+  <p:cSld>
+    <p:spTree>
+      <p:nvGrpSpPr>
+        <p:cNvPr id="1" name=""/>
+        <p:cNvGrpSpPr/>
+        <p:nvPr/>
+      </p:nvGrpSpPr>
+      <p:grpSpPr>
+        <a:xfrm>
+          <a:off x="0" y="0"/>
+          <a:ext cx="0" cy="0"/>
+          <a:chOff x="0" y="0"/>
+          <a:chExt cx="0" cy="0"/>
+        </a:xfrm>
+      </p:grpSpPr>
+      <p:sp>
+        <p:nvSpPr>
+          <p:cNvPr id="2" name="Slide Image Placeholder 1"/>
+          <p:cNvSpPr>
+            <a:spLocks noGrp="1"/>
+          </p:cNvSpPr>
+          <p:nvPr>
+            <p:ph type="sldImg" idx="2"/>
+          </p:nvPr>
+        </p:nvSpPr>
+        <p:spPr/>
+      </p:sp>
+      <p:sp>
+        <p:nvSpPr>
+          <p:cNvPr id="3" name="Notes Placeholder 2"/>
+          <p:cNvSpPr>
+            <a:spLocks noGrp="1"/>
+          </p:cNvSpPr>
+          <p:nvPr>
+            <p:ph type="body" idx="3" sz="quarter"/>
+          </p:nvPr>
+        </p:nvSpPr>
+        <p:spPr/>
+        <p:txBody>
+          <a:bodyPr/>
+          <a:lstStyle/>
+          <a:p>
+            <a:r>
+              <a:t>Primary reading for today. Emphasize legitimacy: professional researchers do this deliberately — theater is a research instrument, not a shortcut.</a:t>
+            </a:r>
+          </a:p>
+        </p:txBody>
+      </p:sp>
+      <p:sp>
+        <p:nvSpPr>
+          <p:cNvPr id="4" name="Slide Number Placeholder 3"/>
+          <p:cNvSpPr>
+            <a:spLocks noGrp="1"/>
+          </p:cNvSpPr>
+          <p:nvPr>
+            <p:ph type="sldNum" idx="5" sz="quarter"/>
+          </p:nvPr>
+        </p:nvSpPr>
+        <p:spPr/>
+      </p:sp>
+    </p:spTree>
+  </p:cSld>
+  <p:clrMapOvr>
+    <a:masterClrMapping/>
+  </p:clrMapOvr>
+</p:notes>
+</file>
+
+<file path=ppt/notesSlides/notesSlide6.xml><?xml version="1.0" encoding="utf-8"?>
+<p:notes xmlns:a="http://schemas.openxmlformats.org/drawingml/2006/main" xmlns:p="http://schemas.openxmlformats.org/presentationml/2006/main" xmlns:r="http://schemas.openxmlformats.org/officeDocument/2006/relationships">
+  <p:cSld>
+    <p:spTree>
+      <p:nvGrpSpPr>
+        <p:cNvPr id="1" name=""/>
+        <p:cNvGrpSpPr/>
+        <p:nvPr/>
+      </p:nvGrpSpPr>
+      <p:grpSpPr>
+        <a:xfrm>
+          <a:off x="0" y="0"/>
+          <a:ext cx="0" cy="0"/>
+          <a:chOff x="0" y="0"/>
+          <a:chExt cx="0" cy="0"/>
+        </a:xfrm>
+      </p:grpSpPr>
+      <p:sp>
+        <p:nvSpPr>
+          <p:cNvPr id="2" name="Slide Image Placeholder 1"/>
+          <p:cNvSpPr>
+            <a:spLocks noGrp="1"/>
+          </p:cNvSpPr>
+          <p:nvPr>
+            <p:ph type="sldImg" idx="2"/>
+          </p:nvPr>
+        </p:nvSpPr>
+        <p:spPr/>
+      </p:sp>
+      <p:sp>
+        <p:nvSpPr>
+          <p:cNvPr id="3" name="Notes Placeholder 2"/>
+          <p:cNvSpPr>
+            <a:spLocks noGrp="1"/>
+          </p:cNvSpPr>
+          <p:nvPr>
+            <p:ph type="body" idx="3" sz="quarter"/>
+          </p:nvPr>
+        </p:nvSpPr>
+        <p:spPr/>
+        <p:txBody>
+          <a:bodyPr/>
+          <a:lstStyle/>
+          <a:p>
+            <a:r>
+              <a:t>Co-Designing with Transformers (DIS '25), doi 10.1145/3715336.3735805. Personal-experience beat: tell the story from the HCI course studies. The acceleration point motivates why one in-class loop is now feasible at all.</a:t>
+            </a:r>
+          </a:p>
+        </p:txBody>
+      </p:sp>
+      <p:sp>
+        <p:nvSpPr>
+          <p:cNvPr id="4" name="Slide Number Placeholder 3"/>
+          <p:cNvSpPr>
+            <a:spLocks noGrp="1"/>
+          </p:cNvSpPr>
+          <p:nvPr>
+            <p:ph type="sldNum" idx="5" sz="quarter"/>
+          </p:nvPr>
+        </p:nvSpPr>
+        <p:spPr/>
+      </p:sp>
+    </p:spTree>
+  </p:cSld>
+  <p:clrMapOvr>
+    <a:masterClrMapping/>
+  </p:clrMapOvr>
+</p:notes>
+</file>
+
+<file path=ppt/notesSlides/notesSlide7.xml><?xml version="1.0" encoding="utf-8"?>
+<p:notes xmlns:a="http://schemas.openxmlformats.org/drawingml/2006/main" xmlns:p="http://schemas.openxmlformats.org/presentationml/2006/main" xmlns:r="http://schemas.openxmlformats.org/officeDocument/2006/relationships">
+  <p:cSld>
+    <p:spTree>
+      <p:nvGrpSpPr>
+        <p:cNvPr id="1" name=""/>
+        <p:cNvGrpSpPr/>
+        <p:nvPr/>
+      </p:nvGrpSpPr>
+      <p:grpSpPr>
+        <a:xfrm>
+          <a:off x="0" y="0"/>
+          <a:ext cx="0" cy="0"/>
+          <a:chOff x="0" y="0"/>
+          <a:chExt cx="0" cy="0"/>
+        </a:xfrm>
+      </p:grpSpPr>
+      <p:sp>
+        <p:nvSpPr>
+          <p:cNvPr id="2" name="Slide Image Placeholder 1"/>
+          <p:cNvSpPr>
+            <a:spLocks noGrp="1"/>
+          </p:cNvSpPr>
+          <p:nvPr>
+            <p:ph type="sldImg" idx="2"/>
+          </p:nvPr>
+        </p:nvSpPr>
+        <p:spPr/>
+      </p:sp>
+      <p:sp>
+        <p:nvSpPr>
+          <p:cNvPr id="3" name="Notes Placeholder 2"/>
+          <p:cNvSpPr>
+            <a:spLocks noGrp="1"/>
+          </p:cNvSpPr>
+          <p:nvPr>
+            <p:ph type="body" idx="3" sz="quarter"/>
+          </p:nvPr>
+        </p:nvSpPr>
+        <p:spPr/>
+        <p:txBody>
+          <a:bodyPr/>
+          <a:lstStyle/>
+          <a:p>
+            <a:r>
+              <a:t>Report template is pre-seeded in the team repo as project-report.md. Ethical reflection and individual reflections are human-written (AI grammar-checking only).</a:t>
             </a:r>
           </a:p>
         </p:txBody>
@@ -3634,7 +4064,1479 @@
                 </a:solidFill>
                 <a:latin typeface="Arial"/>
               </a:rPr>
-              <a:t>Project Day — Project 1</a:t>
+              <a:t>Project Day — Fake It, Then Make It</a:t>
+            </a:r>
+          </a:p>
+        </p:txBody>
+      </p:sp>
+    </p:spTree>
+  </p:cSld>
+  <p:clrMapOvr>
+    <a:masterClrMapping/>
+  </p:clrMapOvr>
+</p:sld>
+</file>
+
+<file path=ppt/slides/slide10.xml><?xml version="1.0" encoding="utf-8"?>
+<p:sld xmlns:a="http://schemas.openxmlformats.org/drawingml/2006/main" xmlns:p="http://schemas.openxmlformats.org/presentationml/2006/main" xmlns:r="http://schemas.openxmlformats.org/officeDocument/2006/relationships">
+  <p:cSld>
+    <p:bg>
+      <p:bgPr>
+        <a:solidFill>
+          <a:srgbClr val="0B0E14"/>
+        </a:solidFill>
+        <a:effectLst/>
+      </p:bgPr>
+    </p:bg>
+    <p:spTree>
+      <p:nvGrpSpPr>
+        <p:cNvPr id="1" name=""/>
+        <p:cNvGrpSpPr/>
+        <p:nvPr/>
+      </p:nvGrpSpPr>
+      <p:grpSpPr/>
+      <p:sp>
+        <p:nvSpPr>
+          <p:cNvPr id="2" name="TextBox 1"/>
+          <p:cNvSpPr txBox="1"/>
+          <p:nvPr/>
+        </p:nvSpPr>
+        <p:spPr>
+          <a:xfrm>
+            <a:off x="640080" y="502920"/>
+            <a:ext cx="10058400" cy="365760"/>
+          </a:xfrm>
+          <a:prstGeom prst="rect">
+            <a:avLst/>
+          </a:prstGeom>
+          <a:noFill/>
+        </p:spPr>
+        <p:txBody>
+          <a:bodyPr wrap="square" anchor="t">
+            <a:spAutoFit/>
+          </a:bodyPr>
+          <a:lstStyle/>
+          <a:p>
+            <a:pPr algn="l">
+              <a:lnSpc>
+                <a:spcPct val="100000"/>
+              </a:lnSpc>
+            </a:pPr>
+            <a:r>
+              <a:rPr sz="1300" b="1">
+                <a:solidFill>
+                  <a:srgbClr val="00FF41"/>
+                </a:solidFill>
+                <a:latin typeface="Courier New"/>
+              </a:rPr>
+              <a:t>TEAMWORK</a:t>
+            </a:r>
+          </a:p>
+        </p:txBody>
+      </p:sp>
+      <p:sp>
+        <p:nvSpPr>
+          <p:cNvPr id="3" name="Rectangle 2"/>
+          <p:cNvSpPr/>
+          <p:nvPr/>
+        </p:nvSpPr>
+        <p:spPr>
+          <a:xfrm>
+            <a:off x="640080" y="932688"/>
+            <a:ext cx="822960" cy="73152"/>
+          </a:xfrm>
+          <a:prstGeom prst="rect">
+            <a:avLst/>
+          </a:prstGeom>
+          <a:solidFill>
+            <a:srgbClr val="00FF41"/>
+          </a:solidFill>
+          <a:ln>
+            <a:noFill/>
+          </a:ln>
+          <a:effectLst/>
+        </p:spPr>
+        <p:style>
+          <a:lnRef idx="1">
+            <a:schemeClr val="accent1"/>
+          </a:lnRef>
+          <a:fillRef idx="3">
+            <a:schemeClr val="accent1"/>
+          </a:fillRef>
+          <a:effectRef idx="2">
+            <a:schemeClr val="accent1"/>
+          </a:effectRef>
+          <a:fontRef idx="minor">
+            <a:schemeClr val="lt1"/>
+          </a:fontRef>
+        </p:style>
+        <p:txBody>
+          <a:bodyPr rtlCol="0" anchor="ctr"/>
+          <a:lstStyle/>
+          <a:p>
+            <a:pPr algn="ctr"/>
+          </a:p>
+        </p:txBody>
+      </p:sp>
+      <p:sp>
+        <p:nvSpPr>
+          <p:cNvPr id="4" name="TextBox 3"/>
+          <p:cNvSpPr txBox="1"/>
+          <p:nvPr/>
+        </p:nvSpPr>
+        <p:spPr>
+          <a:xfrm>
+            <a:off x="640080" y="1188720"/>
+            <a:ext cx="10972800" cy="914400"/>
+          </a:xfrm>
+          <a:prstGeom prst="rect">
+            <a:avLst/>
+          </a:prstGeom>
+          <a:noFill/>
+        </p:spPr>
+        <p:txBody>
+          <a:bodyPr wrap="square" anchor="t">
+            <a:spAutoFit/>
+          </a:bodyPr>
+          <a:lstStyle/>
+          <a:p>
+            <a:pPr algn="l">
+              <a:lnSpc>
+                <a:spcPct val="100000"/>
+              </a:lnSpc>
+            </a:pPr>
+            <a:r>
+              <a:rPr sz="3200" b="1">
+                <a:solidFill>
+                  <a:srgbClr val="F5F7FA"/>
+                </a:solidFill>
+                <a:latin typeface="Arial"/>
+              </a:rPr>
+              <a:t>The focused build — split the roles</a:t>
+            </a:r>
+          </a:p>
+        </p:txBody>
+      </p:sp>
+      <p:sp>
+        <p:nvSpPr>
+          <p:cNvPr id="5" name="Rounded Rectangle 4"/>
+          <p:cNvSpPr/>
+          <p:nvPr/>
+        </p:nvSpPr>
+        <p:spPr>
+          <a:xfrm>
+            <a:off x="640080" y="2468880"/>
+            <a:ext cx="3393338" cy="3383280"/>
+          </a:xfrm>
+          <a:prstGeom prst="roundRect">
+            <a:avLst/>
+          </a:prstGeom>
+          <a:solidFill>
+            <a:srgbClr val="151B26"/>
+          </a:solidFill>
+          <a:ln>
+            <a:noFill/>
+          </a:ln>
+          <a:effectLst/>
+        </p:spPr>
+        <p:style>
+          <a:lnRef idx="1">
+            <a:schemeClr val="accent1"/>
+          </a:lnRef>
+          <a:fillRef idx="3">
+            <a:schemeClr val="accent1"/>
+          </a:fillRef>
+          <a:effectRef idx="2">
+            <a:schemeClr val="accent1"/>
+          </a:effectRef>
+          <a:fontRef idx="minor">
+            <a:schemeClr val="lt1"/>
+          </a:fontRef>
+        </p:style>
+        <p:txBody>
+          <a:bodyPr rtlCol="0" anchor="ctr"/>
+          <a:lstStyle/>
+          <a:p>
+            <a:pPr algn="ctr"/>
+          </a:p>
+        </p:txBody>
+      </p:sp>
+      <p:sp>
+        <p:nvSpPr>
+          <p:cNvPr id="6" name="Rectangle 5"/>
+          <p:cNvSpPr/>
+          <p:nvPr/>
+        </p:nvSpPr>
+        <p:spPr>
+          <a:xfrm>
+            <a:off x="640080" y="2468880"/>
+            <a:ext cx="3393338" cy="82296"/>
+          </a:xfrm>
+          <a:prstGeom prst="rect">
+            <a:avLst/>
+          </a:prstGeom>
+          <a:solidFill>
+            <a:srgbClr val="00FF41"/>
+          </a:solidFill>
+          <a:ln>
+            <a:noFill/>
+          </a:ln>
+          <a:effectLst/>
+        </p:spPr>
+        <p:style>
+          <a:lnRef idx="1">
+            <a:schemeClr val="accent1"/>
+          </a:lnRef>
+          <a:fillRef idx="3">
+            <a:schemeClr val="accent1"/>
+          </a:fillRef>
+          <a:effectRef idx="2">
+            <a:schemeClr val="accent1"/>
+          </a:effectRef>
+          <a:fontRef idx="minor">
+            <a:schemeClr val="lt1"/>
+          </a:fontRef>
+        </p:style>
+        <p:txBody>
+          <a:bodyPr rtlCol="0" anchor="ctr"/>
+          <a:lstStyle/>
+          <a:p>
+            <a:pPr algn="ctr"/>
+          </a:p>
+        </p:txBody>
+      </p:sp>
+      <p:sp>
+        <p:nvSpPr>
+          <p:cNvPr id="7" name="TextBox 6"/>
+          <p:cNvSpPr txBox="1"/>
+          <p:nvPr/>
+        </p:nvSpPr>
+        <p:spPr>
+          <a:xfrm>
+            <a:off x="914400" y="2788920"/>
+            <a:ext cx="2844698" cy="457200"/>
+          </a:xfrm>
+          <a:prstGeom prst="rect">
+            <a:avLst/>
+          </a:prstGeom>
+          <a:noFill/>
+        </p:spPr>
+        <p:txBody>
+          <a:bodyPr wrap="square" anchor="t">
+            <a:spAutoFit/>
+          </a:bodyPr>
+          <a:lstStyle/>
+          <a:p>
+            <a:pPr algn="l">
+              <a:lnSpc>
+                <a:spcPct val="100000"/>
+              </a:lnSpc>
+            </a:pPr>
+            <a:r>
+              <a:rPr sz="1200" b="1">
+                <a:solidFill>
+                  <a:srgbClr val="00FF41"/>
+                </a:solidFill>
+                <a:latin typeface="Courier New"/>
+              </a:rPr>
+              <a:t>THE DESIGNER</a:t>
+            </a:r>
+          </a:p>
+        </p:txBody>
+      </p:sp>
+      <p:sp>
+        <p:nvSpPr>
+          <p:cNvPr id="8" name="TextBox 7"/>
+          <p:cNvSpPr txBox="1"/>
+          <p:nvPr/>
+        </p:nvSpPr>
+        <p:spPr>
+          <a:xfrm>
+            <a:off x="914400" y="3246120"/>
+            <a:ext cx="2844698" cy="822960"/>
+          </a:xfrm>
+          <a:prstGeom prst="rect">
+            <a:avLst/>
+          </a:prstGeom>
+          <a:noFill/>
+        </p:spPr>
+        <p:txBody>
+          <a:bodyPr wrap="square" anchor="t">
+            <a:spAutoFit/>
+          </a:bodyPr>
+          <a:lstStyle/>
+          <a:p>
+            <a:pPr algn="l">
+              <a:lnSpc>
+                <a:spcPct val="100000"/>
+              </a:lnSpc>
+            </a:pPr>
+            <a:r>
+              <a:rPr sz="2000" b="1">
+                <a:solidFill>
+                  <a:srgbClr val="F5F7FA"/>
+                </a:solidFill>
+                <a:latin typeface="Arial"/>
+              </a:rPr>
+              <a:t>Owns the experience</a:t>
+            </a:r>
+          </a:p>
+        </p:txBody>
+      </p:sp>
+      <p:sp>
+        <p:nvSpPr>
+          <p:cNvPr id="9" name="TextBox 8"/>
+          <p:cNvSpPr txBox="1"/>
+          <p:nvPr/>
+        </p:nvSpPr>
+        <p:spPr>
+          <a:xfrm>
+            <a:off x="914400" y="4114800"/>
+            <a:ext cx="2844698" cy="1554480"/>
+          </a:xfrm>
+          <a:prstGeom prst="rect">
+            <a:avLst/>
+          </a:prstGeom>
+          <a:noFill/>
+        </p:spPr>
+        <p:txBody>
+          <a:bodyPr wrap="square" anchor="t">
+            <a:spAutoFit/>
+          </a:bodyPr>
+          <a:lstStyle/>
+          <a:p>
+            <a:pPr algn="l">
+              <a:lnSpc>
+                <a:spcPct val="110000"/>
+              </a:lnSpc>
+            </a:pPr>
+            <a:r>
+              <a:rPr sz="1500" b="0">
+                <a:solidFill>
+                  <a:srgbClr val="8A94A6"/>
+                </a:solidFill>
+                <a:latin typeface="Arial"/>
+              </a:rPr>
+              <a:t>Sketches flows, decides what it should feel like, judges every AI proposal against the user.</a:t>
+            </a:r>
+          </a:p>
+        </p:txBody>
+      </p:sp>
+      <p:sp>
+        <p:nvSpPr>
+          <p:cNvPr id="10" name="Rounded Rectangle 9"/>
+          <p:cNvSpPr/>
+          <p:nvPr/>
+        </p:nvSpPr>
+        <p:spPr>
+          <a:xfrm>
+            <a:off x="4399178" y="2468880"/>
+            <a:ext cx="3393338" cy="3383280"/>
+          </a:xfrm>
+          <a:prstGeom prst="roundRect">
+            <a:avLst/>
+          </a:prstGeom>
+          <a:solidFill>
+            <a:srgbClr val="151B26"/>
+          </a:solidFill>
+          <a:ln>
+            <a:noFill/>
+          </a:ln>
+          <a:effectLst/>
+        </p:spPr>
+        <p:style>
+          <a:lnRef idx="1">
+            <a:schemeClr val="accent1"/>
+          </a:lnRef>
+          <a:fillRef idx="3">
+            <a:schemeClr val="accent1"/>
+          </a:fillRef>
+          <a:effectRef idx="2">
+            <a:schemeClr val="accent1"/>
+          </a:effectRef>
+          <a:fontRef idx="minor">
+            <a:schemeClr val="lt1"/>
+          </a:fontRef>
+        </p:style>
+        <p:txBody>
+          <a:bodyPr rtlCol="0" anchor="ctr"/>
+          <a:lstStyle/>
+          <a:p>
+            <a:pPr algn="ctr"/>
+          </a:p>
+        </p:txBody>
+      </p:sp>
+      <p:sp>
+        <p:nvSpPr>
+          <p:cNvPr id="11" name="Rectangle 10"/>
+          <p:cNvSpPr/>
+          <p:nvPr/>
+        </p:nvSpPr>
+        <p:spPr>
+          <a:xfrm>
+            <a:off x="4399178" y="2468880"/>
+            <a:ext cx="3393338" cy="82296"/>
+          </a:xfrm>
+          <a:prstGeom prst="rect">
+            <a:avLst/>
+          </a:prstGeom>
+          <a:solidFill>
+            <a:srgbClr val="00FF41"/>
+          </a:solidFill>
+          <a:ln>
+            <a:noFill/>
+          </a:ln>
+          <a:effectLst/>
+        </p:spPr>
+        <p:style>
+          <a:lnRef idx="1">
+            <a:schemeClr val="accent1"/>
+          </a:lnRef>
+          <a:fillRef idx="3">
+            <a:schemeClr val="accent1"/>
+          </a:fillRef>
+          <a:effectRef idx="2">
+            <a:schemeClr val="accent1"/>
+          </a:effectRef>
+          <a:fontRef idx="minor">
+            <a:schemeClr val="lt1"/>
+          </a:fontRef>
+        </p:style>
+        <p:txBody>
+          <a:bodyPr rtlCol="0" anchor="ctr"/>
+          <a:lstStyle/>
+          <a:p>
+            <a:pPr algn="ctr"/>
+          </a:p>
+        </p:txBody>
+      </p:sp>
+      <p:sp>
+        <p:nvSpPr>
+          <p:cNvPr id="12" name="TextBox 11"/>
+          <p:cNvSpPr txBox="1"/>
+          <p:nvPr/>
+        </p:nvSpPr>
+        <p:spPr>
+          <a:xfrm>
+            <a:off x="4673498" y="2788920"/>
+            <a:ext cx="2844698" cy="457200"/>
+          </a:xfrm>
+          <a:prstGeom prst="rect">
+            <a:avLst/>
+          </a:prstGeom>
+          <a:noFill/>
+        </p:spPr>
+        <p:txBody>
+          <a:bodyPr wrap="square" anchor="t">
+            <a:spAutoFit/>
+          </a:bodyPr>
+          <a:lstStyle/>
+          <a:p>
+            <a:pPr algn="l">
+              <a:lnSpc>
+                <a:spcPct val="100000"/>
+              </a:lnSpc>
+            </a:pPr>
+            <a:r>
+              <a:rPr sz="1200" b="1">
+                <a:solidFill>
+                  <a:srgbClr val="00FF41"/>
+                </a:solidFill>
+                <a:latin typeface="Courier New"/>
+              </a:rPr>
+              <a:t>THE AI ORCHESTRATOR</a:t>
+            </a:r>
+          </a:p>
+        </p:txBody>
+      </p:sp>
+      <p:sp>
+        <p:nvSpPr>
+          <p:cNvPr id="13" name="TextBox 12"/>
+          <p:cNvSpPr txBox="1"/>
+          <p:nvPr/>
+        </p:nvSpPr>
+        <p:spPr>
+          <a:xfrm>
+            <a:off x="4673498" y="3246120"/>
+            <a:ext cx="2844698" cy="822960"/>
+          </a:xfrm>
+          <a:prstGeom prst="rect">
+            <a:avLst/>
+          </a:prstGeom>
+          <a:noFill/>
+        </p:spPr>
+        <p:txBody>
+          <a:bodyPr wrap="square" anchor="t">
+            <a:spAutoFit/>
+          </a:bodyPr>
+          <a:lstStyle/>
+          <a:p>
+            <a:pPr algn="l">
+              <a:lnSpc>
+                <a:spcPct val="100000"/>
+              </a:lnSpc>
+            </a:pPr>
+            <a:r>
+              <a:rPr sz="2000" b="1">
+                <a:solidFill>
+                  <a:srgbClr val="F5F7FA"/>
+                </a:solidFill>
+                <a:latin typeface="Arial"/>
+              </a:rPr>
+              <a:t>Drives the tools</a:t>
+            </a:r>
+          </a:p>
+        </p:txBody>
+      </p:sp>
+      <p:sp>
+        <p:nvSpPr>
+          <p:cNvPr id="14" name="TextBox 13"/>
+          <p:cNvSpPr txBox="1"/>
+          <p:nvPr/>
+        </p:nvSpPr>
+        <p:spPr>
+          <a:xfrm>
+            <a:off x="4673498" y="4114800"/>
+            <a:ext cx="2844698" cy="1554480"/>
+          </a:xfrm>
+          <a:prstGeom prst="rect">
+            <a:avLst/>
+          </a:prstGeom>
+          <a:noFill/>
+        </p:spPr>
+        <p:txBody>
+          <a:bodyPr wrap="square" anchor="t">
+            <a:spAutoFit/>
+          </a:bodyPr>
+          <a:lstStyle/>
+          <a:p>
+            <a:pPr algn="l">
+              <a:lnSpc>
+                <a:spcPct val="110000"/>
+              </a:lnSpc>
+            </a:pPr>
+            <a:r>
+              <a:rPr sz="1500" b="0">
+                <a:solidFill>
+                  <a:srgbClr val="8A94A6"/>
+                </a:solidFill>
+                <a:latin typeface="Arial"/>
+              </a:rPr>
+              <a:t>Writes the prompts, manages context, keeps the Vibe-Trace log honest.</a:t>
+            </a:r>
+          </a:p>
+        </p:txBody>
+      </p:sp>
+      <p:sp>
+        <p:nvSpPr>
+          <p:cNvPr id="15" name="Rounded Rectangle 14"/>
+          <p:cNvSpPr/>
+          <p:nvPr/>
+        </p:nvSpPr>
+        <p:spPr>
+          <a:xfrm>
+            <a:off x="8158276" y="2468880"/>
+            <a:ext cx="3393338" cy="3383280"/>
+          </a:xfrm>
+          <a:prstGeom prst="roundRect">
+            <a:avLst/>
+          </a:prstGeom>
+          <a:solidFill>
+            <a:srgbClr val="151B26"/>
+          </a:solidFill>
+          <a:ln>
+            <a:noFill/>
+          </a:ln>
+          <a:effectLst/>
+        </p:spPr>
+        <p:style>
+          <a:lnRef idx="1">
+            <a:schemeClr val="accent1"/>
+          </a:lnRef>
+          <a:fillRef idx="3">
+            <a:schemeClr val="accent1"/>
+          </a:fillRef>
+          <a:effectRef idx="2">
+            <a:schemeClr val="accent1"/>
+          </a:effectRef>
+          <a:fontRef idx="minor">
+            <a:schemeClr val="lt1"/>
+          </a:fontRef>
+        </p:style>
+        <p:txBody>
+          <a:bodyPr rtlCol="0" anchor="ctr"/>
+          <a:lstStyle/>
+          <a:p>
+            <a:pPr algn="ctr"/>
+          </a:p>
+        </p:txBody>
+      </p:sp>
+      <p:sp>
+        <p:nvSpPr>
+          <p:cNvPr id="16" name="Rectangle 15"/>
+          <p:cNvSpPr/>
+          <p:nvPr/>
+        </p:nvSpPr>
+        <p:spPr>
+          <a:xfrm>
+            <a:off x="8158276" y="2468880"/>
+            <a:ext cx="3393338" cy="82296"/>
+          </a:xfrm>
+          <a:prstGeom prst="rect">
+            <a:avLst/>
+          </a:prstGeom>
+          <a:solidFill>
+            <a:srgbClr val="00FF41"/>
+          </a:solidFill>
+          <a:ln>
+            <a:noFill/>
+          </a:ln>
+          <a:effectLst/>
+        </p:spPr>
+        <p:style>
+          <a:lnRef idx="1">
+            <a:schemeClr val="accent1"/>
+          </a:lnRef>
+          <a:fillRef idx="3">
+            <a:schemeClr val="accent1"/>
+          </a:fillRef>
+          <a:effectRef idx="2">
+            <a:schemeClr val="accent1"/>
+          </a:effectRef>
+          <a:fontRef idx="minor">
+            <a:schemeClr val="lt1"/>
+          </a:fontRef>
+        </p:style>
+        <p:txBody>
+          <a:bodyPr rtlCol="0" anchor="ctr"/>
+          <a:lstStyle/>
+          <a:p>
+            <a:pPr algn="ctr"/>
+          </a:p>
+        </p:txBody>
+      </p:sp>
+      <p:sp>
+        <p:nvSpPr>
+          <p:cNvPr id="17" name="TextBox 16"/>
+          <p:cNvSpPr txBox="1"/>
+          <p:nvPr/>
+        </p:nvSpPr>
+        <p:spPr>
+          <a:xfrm>
+            <a:off x="8432596" y="2788920"/>
+            <a:ext cx="2844698" cy="457200"/>
+          </a:xfrm>
+          <a:prstGeom prst="rect">
+            <a:avLst/>
+          </a:prstGeom>
+          <a:noFill/>
+        </p:spPr>
+        <p:txBody>
+          <a:bodyPr wrap="square" anchor="t">
+            <a:spAutoFit/>
+          </a:bodyPr>
+          <a:lstStyle/>
+          <a:p>
+            <a:pPr algn="l">
+              <a:lnSpc>
+                <a:spcPct val="100000"/>
+              </a:lnSpc>
+            </a:pPr>
+            <a:r>
+              <a:rPr sz="1200" b="1">
+                <a:solidFill>
+                  <a:srgbClr val="00FF41"/>
+                </a:solidFill>
+                <a:latin typeface="Courier New"/>
+              </a:rPr>
+              <a:t>THE ARCHITECT</a:t>
+            </a:r>
+          </a:p>
+        </p:txBody>
+      </p:sp>
+      <p:sp>
+        <p:nvSpPr>
+          <p:cNvPr id="18" name="TextBox 17"/>
+          <p:cNvSpPr txBox="1"/>
+          <p:nvPr/>
+        </p:nvSpPr>
+        <p:spPr>
+          <a:xfrm>
+            <a:off x="8432596" y="3246120"/>
+            <a:ext cx="2844698" cy="822960"/>
+          </a:xfrm>
+          <a:prstGeom prst="rect">
+            <a:avLst/>
+          </a:prstGeom>
+          <a:noFill/>
+        </p:spPr>
+        <p:txBody>
+          <a:bodyPr wrap="square" anchor="t">
+            <a:spAutoFit/>
+          </a:bodyPr>
+          <a:lstStyle/>
+          <a:p>
+            <a:pPr algn="l">
+              <a:lnSpc>
+                <a:spcPct val="100000"/>
+              </a:lnSpc>
+            </a:pPr>
+            <a:r>
+              <a:rPr sz="2000" b="1">
+                <a:solidFill>
+                  <a:srgbClr val="F5F7FA"/>
+                </a:solidFill>
+                <a:latin typeface="Arial"/>
+              </a:rPr>
+              <a:t>Owns the structure</a:t>
+            </a:r>
+          </a:p>
+        </p:txBody>
+      </p:sp>
+      <p:sp>
+        <p:nvSpPr>
+          <p:cNvPr id="19" name="TextBox 18"/>
+          <p:cNvSpPr txBox="1"/>
+          <p:nvPr/>
+        </p:nvSpPr>
+        <p:spPr>
+          <a:xfrm>
+            <a:off x="8432596" y="4114800"/>
+            <a:ext cx="2844698" cy="1554480"/>
+          </a:xfrm>
+          <a:prstGeom prst="rect">
+            <a:avLst/>
+          </a:prstGeom>
+          <a:noFill/>
+        </p:spPr>
+        <p:txBody>
+          <a:bodyPr wrap="square" anchor="t">
+            <a:spAutoFit/>
+          </a:bodyPr>
+          <a:lstStyle/>
+          <a:p>
+            <a:pPr algn="l">
+              <a:lnSpc>
+                <a:spcPct val="110000"/>
+              </a:lnSpc>
+            </a:pPr>
+            <a:r>
+              <a:rPr sz="1500" b="0">
+                <a:solidFill>
+                  <a:srgbClr val="8A94A6"/>
+                </a:solidFill>
+                <a:latin typeface="Arial"/>
+              </a:rPr>
+              <a:t>Decides file layout, data flow, hosting — keeps the AI's code explainable.</a:t>
+            </a:r>
+          </a:p>
+        </p:txBody>
+      </p:sp>
+      <p:sp>
+        <p:nvSpPr>
+          <p:cNvPr id="20" name="TextBox 19"/>
+          <p:cNvSpPr txBox="1"/>
+          <p:nvPr/>
+        </p:nvSpPr>
+        <p:spPr>
+          <a:xfrm>
+            <a:off x="640080" y="6355080"/>
+            <a:ext cx="10972800" cy="365760"/>
+          </a:xfrm>
+          <a:prstGeom prst="rect">
+            <a:avLst/>
+          </a:prstGeom>
+          <a:noFill/>
+        </p:spPr>
+        <p:txBody>
+          <a:bodyPr wrap="square" anchor="t">
+            <a:spAutoFit/>
+          </a:bodyPr>
+          <a:lstStyle/>
+          <a:p>
+            <a:pPr algn="l">
+              <a:lnSpc>
+                <a:spcPct val="100000"/>
+              </a:lnSpc>
+            </a:pPr>
+            <a:r>
+              <a:rPr sz="1000" b="0">
+                <a:solidFill>
+                  <a:srgbClr val="5A6474"/>
+                </a:solidFill>
+                <a:latin typeface="Courier New"/>
+              </a:rPr>
+              <a:t>Good Code, Good Vibes · TECHIE 1121 · Cornell Tech · Summer 2026</a:t>
+            </a:r>
+          </a:p>
+        </p:txBody>
+      </p:sp>
+    </p:spTree>
+  </p:cSld>
+  <p:clrMapOvr>
+    <a:masterClrMapping/>
+  </p:clrMapOvr>
+</p:sld>
+</file>
+
+<file path=ppt/slides/slide11.xml><?xml version="1.0" encoding="utf-8"?>
+<p:sld xmlns:a="http://schemas.openxmlformats.org/drawingml/2006/main" xmlns:p="http://schemas.openxmlformats.org/presentationml/2006/main" xmlns:r="http://schemas.openxmlformats.org/officeDocument/2006/relationships">
+  <p:cSld>
+    <p:bg>
+      <p:bgPr>
+        <a:solidFill>
+          <a:srgbClr val="0B0E14"/>
+        </a:solidFill>
+        <a:effectLst/>
+      </p:bgPr>
+    </p:bg>
+    <p:spTree>
+      <p:nvGrpSpPr>
+        <p:cNvPr id="1" name=""/>
+        <p:cNvGrpSpPr/>
+        <p:nvPr/>
+      </p:nvGrpSpPr>
+      <p:grpSpPr/>
+      <p:sp>
+        <p:nvSpPr>
+          <p:cNvPr id="2" name="TextBox 1"/>
+          <p:cNvSpPr txBox="1"/>
+          <p:nvPr/>
+        </p:nvSpPr>
+        <p:spPr>
+          <a:xfrm>
+            <a:off x="640080" y="502920"/>
+            <a:ext cx="10058400" cy="365760"/>
+          </a:xfrm>
+          <a:prstGeom prst="rect">
+            <a:avLst/>
+          </a:prstGeom>
+          <a:noFill/>
+        </p:spPr>
+        <p:txBody>
+          <a:bodyPr wrap="square" anchor="t">
+            <a:spAutoFit/>
+          </a:bodyPr>
+          <a:lstStyle/>
+          <a:p>
+            <a:pPr algn="l">
+              <a:lnSpc>
+                <a:spcPct val="100000"/>
+              </a:lnSpc>
+            </a:pPr>
+            <a:r>
+              <a:rPr sz="1300" b="1">
+                <a:solidFill>
+                  <a:srgbClr val="00FF41"/>
+                </a:solidFill>
+                <a:latin typeface="Courier New"/>
+              </a:rPr>
+              <a:t>RUN THE TEST</a:t>
+            </a:r>
+          </a:p>
+        </p:txBody>
+      </p:sp>
+      <p:sp>
+        <p:nvSpPr>
+          <p:cNvPr id="3" name="Rectangle 2"/>
+          <p:cNvSpPr/>
+          <p:nvPr/>
+        </p:nvSpPr>
+        <p:spPr>
+          <a:xfrm>
+            <a:off x="640080" y="932688"/>
+            <a:ext cx="822960" cy="73152"/>
+          </a:xfrm>
+          <a:prstGeom prst="rect">
+            <a:avLst/>
+          </a:prstGeom>
+          <a:solidFill>
+            <a:srgbClr val="00FF41"/>
+          </a:solidFill>
+          <a:ln>
+            <a:noFill/>
+          </a:ln>
+          <a:effectLst/>
+        </p:spPr>
+        <p:style>
+          <a:lnRef idx="1">
+            <a:schemeClr val="accent1"/>
+          </a:lnRef>
+          <a:fillRef idx="3">
+            <a:schemeClr val="accent1"/>
+          </a:fillRef>
+          <a:effectRef idx="2">
+            <a:schemeClr val="accent1"/>
+          </a:effectRef>
+          <a:fontRef idx="minor">
+            <a:schemeClr val="lt1"/>
+          </a:fontRef>
+        </p:style>
+        <p:txBody>
+          <a:bodyPr rtlCol="0" anchor="ctr"/>
+          <a:lstStyle/>
+          <a:p>
+            <a:pPr algn="ctr"/>
+          </a:p>
+        </p:txBody>
+      </p:sp>
+      <p:sp>
+        <p:nvSpPr>
+          <p:cNvPr id="4" name="TextBox 3"/>
+          <p:cNvSpPr txBox="1"/>
+          <p:nvPr/>
+        </p:nvSpPr>
+        <p:spPr>
+          <a:xfrm>
+            <a:off x="640080" y="1188720"/>
+            <a:ext cx="10972800" cy="914400"/>
+          </a:xfrm>
+          <a:prstGeom prst="rect">
+            <a:avLst/>
+          </a:prstGeom>
+          <a:noFill/>
+        </p:spPr>
+        <p:txBody>
+          <a:bodyPr wrap="square" anchor="t">
+            <a:spAutoFit/>
+          </a:bodyPr>
+          <a:lstStyle/>
+          <a:p>
+            <a:pPr algn="l">
+              <a:lnSpc>
+                <a:spcPct val="100000"/>
+              </a:lnSpc>
+            </a:pPr>
+            <a:r>
+              <a:rPr sz="3400" b="1">
+                <a:solidFill>
+                  <a:srgbClr val="F5F7FA"/>
+                </a:solidFill>
+                <a:latin typeface="Arial"/>
+              </a:rPr>
+              <a:t>How to run your fake-it test</a:t>
+            </a:r>
+          </a:p>
+        </p:txBody>
+      </p:sp>
+      <p:sp>
+        <p:nvSpPr>
+          <p:cNvPr id="5" name="TextBox 4"/>
+          <p:cNvSpPr txBox="1"/>
+          <p:nvPr/>
+        </p:nvSpPr>
+        <p:spPr>
+          <a:xfrm>
+            <a:off x="822960" y="2286000"/>
+            <a:ext cx="10515600" cy="3840480"/>
+          </a:xfrm>
+          <a:prstGeom prst="rect">
+            <a:avLst/>
+          </a:prstGeom>
+          <a:noFill/>
+        </p:spPr>
+        <p:txBody>
+          <a:bodyPr wrap="square" anchor="t">
+            <a:spAutoFit/>
+          </a:bodyPr>
+          <a:lstStyle/>
+          <a:p>
+            <a:pPr algn="l">
+              <a:lnSpc>
+                <a:spcPct val="135000"/>
+              </a:lnSpc>
+            </a:pPr>
+            <a:r>
+              <a:rPr sz="2000" b="1">
+                <a:solidFill>
+                  <a:srgbClr val="00FF41"/>
+                </a:solidFill>
+                <a:latin typeface="Arial"/>
+              </a:rPr>
+              <a:t>✓  </a:t>
+            </a:r>
+            <a:r>
+              <a:rPr sz="2000" b="0">
+                <a:solidFill>
+                  <a:srgbClr val="F5F7FA"/>
+                </a:solidFill>
+                <a:latin typeface="Arial"/>
+              </a:rPr>
+              <a:t>Give the tester ONE task ('split last night's dinner bill') — not a tour of features.</a:t>
+            </a:r>
+          </a:p>
+          <a:p>
+            <a:pPr algn="l">
+              <a:lnSpc>
+                <a:spcPct val="135000"/>
+              </a:lnSpc>
+            </a:pPr>
+            <a:r>
+              <a:rPr sz="2000" b="1">
+                <a:solidFill>
+                  <a:srgbClr val="00FF41"/>
+                </a:solidFill>
+                <a:latin typeface="Arial"/>
+              </a:rPr>
+              <a:t>✓  </a:t>
+            </a:r>
+            <a:r>
+              <a:rPr sz="2000" b="0">
+                <a:solidFill>
+                  <a:srgbClr val="F5F7FA"/>
+                </a:solidFill>
+                <a:latin typeface="Arial"/>
+              </a:rPr>
+              <a:t>Act the whole flow through, start to finish, realistically — theater, not description.</a:t>
+            </a:r>
+          </a:p>
+          <a:p>
+            <a:pPr algn="l">
+              <a:lnSpc>
+                <a:spcPct val="135000"/>
+              </a:lnSpc>
+            </a:pPr>
+            <a:r>
+              <a:rPr sz="2000" b="1">
+                <a:solidFill>
+                  <a:srgbClr val="00FF41"/>
+                </a:solidFill>
+                <a:latin typeface="Arial"/>
+              </a:rPr>
+              <a:t>✓  </a:t>
+            </a:r>
+            <a:r>
+              <a:rPr sz="2000" b="0">
+                <a:solidFill>
+                  <a:srgbClr val="F5F7FA"/>
+                </a:solidFill>
+                <a:latin typeface="Arial"/>
+              </a:rPr>
+              <a:t>Watch what they DO: hesitations, wrong turns, questions. Don't explain, don't rescue.</a:t>
+            </a:r>
+          </a:p>
+          <a:p>
+            <a:pPr algn="l">
+              <a:lnSpc>
+                <a:spcPct val="135000"/>
+              </a:lnSpc>
+            </a:pPr>
+            <a:r>
+              <a:rPr sz="2000" b="1">
+                <a:solidFill>
+                  <a:srgbClr val="00FF41"/>
+                </a:solidFill>
+                <a:latin typeface="Arial"/>
+              </a:rPr>
+              <a:t>✓  </a:t>
+            </a:r>
+            <a:r>
+              <a:rPr sz="2000" b="0">
+                <a:solidFill>
+                  <a:srgbClr val="F5F7FA"/>
+                </a:solidFill>
+                <a:latin typeface="Arial"/>
+              </a:rPr>
+              <a:t>Afterwards ask: what did you think just happened? What would you use this for?</a:t>
+            </a:r>
+          </a:p>
+          <a:p>
+            <a:pPr algn="l">
+              <a:lnSpc>
+                <a:spcPct val="135000"/>
+              </a:lnSpc>
+            </a:pPr>
+            <a:r>
+              <a:rPr sz="2000" b="1">
+                <a:solidFill>
+                  <a:srgbClr val="00FF41"/>
+                </a:solidFill>
+                <a:latin typeface="Arial"/>
+              </a:rPr>
+              <a:t>✓  </a:t>
+            </a:r>
+            <a:r>
+              <a:rPr sz="2000" b="0">
+                <a:solidFill>
+                  <a:srgbClr val="F5F7FA"/>
+                </a:solidFill>
+                <a:latin typeface="Arial"/>
+              </a:rPr>
+              <a:t>Then decide as a team: right problem? right scope? Write the re-scope decision down.</a:t>
+            </a:r>
+          </a:p>
+        </p:txBody>
+      </p:sp>
+      <p:sp>
+        <p:nvSpPr>
+          <p:cNvPr id="6" name="TextBox 5"/>
+          <p:cNvSpPr txBox="1"/>
+          <p:nvPr/>
+        </p:nvSpPr>
+        <p:spPr>
+          <a:xfrm>
+            <a:off x="640080" y="6355080"/>
+            <a:ext cx="10972800" cy="365760"/>
+          </a:xfrm>
+          <a:prstGeom prst="rect">
+            <a:avLst/>
+          </a:prstGeom>
+          <a:noFill/>
+        </p:spPr>
+        <p:txBody>
+          <a:bodyPr wrap="square" anchor="t">
+            <a:spAutoFit/>
+          </a:bodyPr>
+          <a:lstStyle/>
+          <a:p>
+            <a:pPr algn="l">
+              <a:lnSpc>
+                <a:spcPct val="100000"/>
+              </a:lnSpc>
+            </a:pPr>
+            <a:r>
+              <a:rPr sz="1000" b="0">
+                <a:solidFill>
+                  <a:srgbClr val="5A6474"/>
+                </a:solidFill>
+                <a:latin typeface="Courier New"/>
+              </a:rPr>
+              <a:t>Good Code, Good Vibes · TECHIE 1121 · Cornell Tech · Summer 2026</a:t>
+            </a:r>
+          </a:p>
+        </p:txBody>
+      </p:sp>
+    </p:spTree>
+  </p:cSld>
+  <p:clrMapOvr>
+    <a:masterClrMapping/>
+  </p:clrMapOvr>
+</p:sld>
+</file>
+
+<file path=ppt/slides/slide12.xml><?xml version="1.0" encoding="utf-8"?>
+<p:sld xmlns:a="http://schemas.openxmlformats.org/drawingml/2006/main" xmlns:p="http://schemas.openxmlformats.org/presentationml/2006/main" xmlns:r="http://schemas.openxmlformats.org/officeDocument/2006/relationships">
+  <p:cSld>
+    <p:bg>
+      <p:bgPr>
+        <a:solidFill>
+          <a:srgbClr val="0B0E14"/>
+        </a:solidFill>
+        <a:effectLst/>
+      </p:bgPr>
+    </p:bg>
+    <p:spTree>
+      <p:nvGrpSpPr>
+        <p:cNvPr id="1" name=""/>
+        <p:cNvGrpSpPr/>
+        <p:nvPr/>
+      </p:nvGrpSpPr>
+      <p:grpSpPr/>
+      <p:sp>
+        <p:nvSpPr>
+          <p:cNvPr id="2" name="TextBox 1"/>
+          <p:cNvSpPr txBox="1"/>
+          <p:nvPr/>
+        </p:nvSpPr>
+        <p:spPr>
+          <a:xfrm>
+            <a:off x="640080" y="502920"/>
+            <a:ext cx="10058400" cy="365760"/>
+          </a:xfrm>
+          <a:prstGeom prst="rect">
+            <a:avLst/>
+          </a:prstGeom>
+          <a:noFill/>
+        </p:spPr>
+        <p:txBody>
+          <a:bodyPr wrap="square" anchor="t">
+            <a:spAutoFit/>
+          </a:bodyPr>
+          <a:lstStyle/>
+          <a:p>
+            <a:pPr algn="l">
+              <a:lnSpc>
+                <a:spcPct val="100000"/>
+              </a:lnSpc>
+            </a:pPr>
+            <a:r>
+              <a:rPr sz="1300" b="1">
+                <a:solidFill>
+                  <a:srgbClr val="00FF41"/>
+                </a:solidFill>
+                <a:latin typeface="Courier New"/>
+              </a:rPr>
+              <a:t>DELIVERABLES</a:t>
+            </a:r>
+          </a:p>
+        </p:txBody>
+      </p:sp>
+      <p:sp>
+        <p:nvSpPr>
+          <p:cNvPr id="3" name="Rectangle 2"/>
+          <p:cNvSpPr/>
+          <p:nvPr/>
+        </p:nvSpPr>
+        <p:spPr>
+          <a:xfrm>
+            <a:off x="640080" y="932688"/>
+            <a:ext cx="822960" cy="73152"/>
+          </a:xfrm>
+          <a:prstGeom prst="rect">
+            <a:avLst/>
+          </a:prstGeom>
+          <a:solidFill>
+            <a:srgbClr val="00FF41"/>
+          </a:solidFill>
+          <a:ln>
+            <a:noFill/>
+          </a:ln>
+          <a:effectLst/>
+        </p:spPr>
+        <p:style>
+          <a:lnRef idx="1">
+            <a:schemeClr val="accent1"/>
+          </a:lnRef>
+          <a:fillRef idx="3">
+            <a:schemeClr val="accent1"/>
+          </a:fillRef>
+          <a:effectRef idx="2">
+            <a:schemeClr val="accent1"/>
+          </a:effectRef>
+          <a:fontRef idx="minor">
+            <a:schemeClr val="lt1"/>
+          </a:fontRef>
+        </p:style>
+        <p:txBody>
+          <a:bodyPr rtlCol="0" anchor="ctr"/>
+          <a:lstStyle/>
+          <a:p>
+            <a:pPr algn="ctr"/>
+          </a:p>
+        </p:txBody>
+      </p:sp>
+      <p:sp>
+        <p:nvSpPr>
+          <p:cNvPr id="4" name="TextBox 3"/>
+          <p:cNvSpPr txBox="1"/>
+          <p:nvPr/>
+        </p:nvSpPr>
+        <p:spPr>
+          <a:xfrm>
+            <a:off x="640080" y="1188720"/>
+            <a:ext cx="10972800" cy="1097280"/>
+          </a:xfrm>
+          <a:prstGeom prst="rect">
+            <a:avLst/>
+          </a:prstGeom>
+          <a:noFill/>
+        </p:spPr>
+        <p:txBody>
+          <a:bodyPr wrap="square" anchor="t">
+            <a:spAutoFit/>
+          </a:bodyPr>
+          <a:lstStyle/>
+          <a:p>
+            <a:pPr algn="l">
+              <a:lnSpc>
+                <a:spcPct val="100000"/>
+              </a:lnSpc>
+            </a:pPr>
+            <a:r>
+              <a:rPr sz="3400" b="1">
+                <a:solidFill>
+                  <a:srgbClr val="F5F7FA"/>
+                </a:solidFill>
+                <a:latin typeface="Arial"/>
+              </a:rPr>
+              <a:t>What's due Monday (before class)</a:t>
+            </a:r>
+          </a:p>
+        </p:txBody>
+      </p:sp>
+      <p:sp>
+        <p:nvSpPr>
+          <p:cNvPr id="5" name="TextBox 4"/>
+          <p:cNvSpPr txBox="1"/>
+          <p:nvPr/>
+        </p:nvSpPr>
+        <p:spPr>
+          <a:xfrm>
+            <a:off x="658368" y="2286000"/>
+            <a:ext cx="10881360" cy="3657600"/>
+          </a:xfrm>
+          <a:prstGeom prst="rect">
+            <a:avLst/>
+          </a:prstGeom>
+          <a:noFill/>
+        </p:spPr>
+        <p:txBody>
+          <a:bodyPr wrap="square" anchor="t">
+            <a:spAutoFit/>
+          </a:bodyPr>
+          <a:lstStyle/>
+          <a:p>
+            <a:pPr algn="l">
+              <a:lnSpc>
+                <a:spcPct val="112000"/>
+              </a:lnSpc>
+            </a:pPr>
+            <a:r>
+              <a:rPr sz="2000" b="1">
+                <a:solidFill>
+                  <a:srgbClr val="00FF41"/>
+                </a:solidFill>
+                <a:latin typeface="Arial"/>
+              </a:rPr>
+              <a:t>•  </a:t>
+            </a:r>
+            <a:r>
+              <a:rPr sz="2000" b="0">
+                <a:solidFill>
+                  <a:srgbClr val="F5F7FA"/>
+                </a:solidFill>
+                <a:latin typeface="Arial"/>
+              </a:rPr>
+              <a:t>Hosted app — live link, source in code_deliverable/.</a:t>
+            </a:r>
+          </a:p>
+          <a:p>
+            <a:pPr algn="l">
+              <a:lnSpc>
+                <a:spcPct val="112000"/>
+              </a:lnSpc>
+            </a:pPr>
+            <a:r>
+              <a:rPr sz="2000" b="1">
+                <a:solidFill>
+                  <a:srgbClr val="00FF41"/>
+                </a:solidFill>
+                <a:latin typeface="Arial"/>
+              </a:rPr>
+              <a:t>•  </a:t>
+            </a:r>
+            <a:r>
+              <a:rPr sz="2000" b="0">
+                <a:solidFill>
+                  <a:srgbClr val="F5F7FA"/>
+                </a:solidFill>
+                <a:latin typeface="Arial"/>
+              </a:rPr>
+              <a:t>AI interaction log — history.md (Vibe-Trace fills it; verify everyone's prompts show up).</a:t>
+            </a:r>
+          </a:p>
+          <a:p>
+            <a:pPr algn="l">
+              <a:lnSpc>
+                <a:spcPct val="112000"/>
+              </a:lnSpc>
+            </a:pPr>
+            <a:r>
+              <a:rPr sz="2000" b="1">
+                <a:solidFill>
+                  <a:srgbClr val="00FF41"/>
+                </a:solidFill>
+                <a:latin typeface="Arial"/>
+              </a:rPr>
+              <a:t>•  </a:t>
+            </a:r>
+            <a:r>
+              <a:rPr sz="2000" b="0">
+                <a:solidFill>
+                  <a:srgbClr val="F5F7FA"/>
+                </a:solidFill>
+                <a:latin typeface="Arial"/>
+              </a:rPr>
+              <a:t>Project report — fake-it loop record, re-scope decision, role split, team ethical reflection.</a:t>
+            </a:r>
+          </a:p>
+          <a:p>
+            <a:pPr algn="l">
+              <a:lnSpc>
+                <a:spcPct val="112000"/>
+              </a:lnSpc>
+            </a:pPr>
+            <a:r>
+              <a:rPr sz="2000" b="1">
+                <a:solidFill>
+                  <a:srgbClr val="00FF41"/>
+                </a:solidFill>
+                <a:latin typeface="Arial"/>
+              </a:rPr>
+              <a:t>•  </a:t>
+            </a:r>
+            <a:r>
+              <a:rPr sz="2000" b="0">
+                <a:solidFill>
+                  <a:srgbClr val="F5F7FA"/>
+                </a:solidFill>
+                <a:latin typeface="Arial"/>
+              </a:rPr>
+              <a:t>Individual reflections — every member, human-written: collaborating with humans, collaborating with AI.</a:t>
+            </a:r>
+          </a:p>
+          <a:p>
+            <a:pPr algn="l">
+              <a:lnSpc>
+                <a:spcPct val="112000"/>
+              </a:lnSpc>
+            </a:pPr>
+            <a:r>
+              <a:rPr sz="2000" b="1">
+                <a:solidFill>
+                  <a:srgbClr val="00FF41"/>
+                </a:solidFill>
+                <a:latin typeface="Arial"/>
+              </a:rPr>
+              <a:t>•  </a:t>
+            </a:r>
+            <a:r>
+              <a:rPr sz="2000" b="0">
+                <a:solidFill>
+                  <a:srgbClr val="F5F7FA"/>
+                </a:solidFill>
+                <a:latin typeface="Arial"/>
+              </a:rPr>
+              <a:t>Your team decides how much time to invest — a sharp scope decision beats hours of extra features.</a:t>
+            </a:r>
+          </a:p>
+        </p:txBody>
+      </p:sp>
+      <p:sp>
+        <p:nvSpPr>
+          <p:cNvPr id="6" name="TextBox 5"/>
+          <p:cNvSpPr txBox="1"/>
+          <p:nvPr/>
+        </p:nvSpPr>
+        <p:spPr>
+          <a:xfrm>
+            <a:off x="640080" y="6355080"/>
+            <a:ext cx="10972800" cy="365760"/>
+          </a:xfrm>
+          <a:prstGeom prst="rect">
+            <a:avLst/>
+          </a:prstGeom>
+          <a:noFill/>
+        </p:spPr>
+        <p:txBody>
+          <a:bodyPr wrap="square" anchor="t">
+            <a:spAutoFit/>
+          </a:bodyPr>
+          <a:lstStyle/>
+          <a:p>
+            <a:pPr algn="l">
+              <a:lnSpc>
+                <a:spcPct val="100000"/>
+              </a:lnSpc>
+            </a:pPr>
+            <a:r>
+              <a:rPr sz="1000" b="0">
+                <a:solidFill>
+                  <a:srgbClr val="5A6474"/>
+                </a:solidFill>
+                <a:latin typeface="Courier New"/>
+              </a:rPr>
+              <a:t>Good Code, Good Vibes · TECHIE 1121 · Cornell Tech · Summer 2026</a:t>
             </a:r>
           </a:p>
         </p:txBody>
@@ -3855,7 +5757,7 @@
                 </a:solidFill>
                 <a:latin typeface="Arial"/>
               </a:rPr>
-              <a:t>Pick a real problem your team has and ship a small hosted app for it.</a:t>
+              <a:t>Pick a real problem from a team member's own life and ship a small hosted app for it.</a:t>
             </a:r>
           </a:p>
           <a:p>
@@ -3905,7 +5807,7 @@
                 </a:solidFill>
                 <a:latin typeface="Arial"/>
               </a:rPr>
-              <a:t>Deliverable: hosted link + a vibe report (tool choice, prompt log, what broke).</a:t>
+              <a:t>It must DO something, be hosted and reachable by link, and be vibe-coded — prompt trail included.</a:t>
             </a:r>
           </a:p>
           <a:p>
@@ -3930,7 +5832,2805 @@
                 </a:solidFill>
                 <a:latin typeface="Arial"/>
               </a:rPr>
-              <a:t>Work happens in your team’s Group Project repo. Due Monday of Week 2, before class.</a:t>
+              <a:t>Accept the team assignment: classroom.github.com/a/fw74T59W — one member creates the team, the others join.</a:t>
+            </a:r>
+          </a:p>
+          <a:p>
+            <a:pPr algn="l">
+              <a:lnSpc>
+                <a:spcPct val="112000"/>
+              </a:lnSpc>
+            </a:pPr>
+            <a:r>
+              <a:rPr sz="2000" b="1">
+                <a:solidFill>
+                  <a:srgbClr val="00FF41"/>
+                </a:solidFill>
+                <a:latin typeface="Arial"/>
+              </a:rPr>
+              <a:t>•  </a:t>
+            </a:r>
+            <a:r>
+              <a:rPr sz="2000" b="0">
+                <a:solidFill>
+                  <a:srgbClr val="F5F7FA"/>
+                </a:solidFill>
+                <a:latin typeface="Arial"/>
+              </a:rPr>
+              <a:t>Due Monday of Week 2, before class.</a:t>
+            </a:r>
+          </a:p>
+        </p:txBody>
+      </p:sp>
+      <p:sp>
+        <p:nvSpPr>
+          <p:cNvPr id="6" name="TextBox 5"/>
+          <p:cNvSpPr txBox="1"/>
+          <p:nvPr/>
+        </p:nvSpPr>
+        <p:spPr>
+          <a:xfrm>
+            <a:off x="640080" y="6355080"/>
+            <a:ext cx="10972800" cy="365760"/>
+          </a:xfrm>
+          <a:prstGeom prst="rect">
+            <a:avLst/>
+          </a:prstGeom>
+          <a:noFill/>
+        </p:spPr>
+        <p:txBody>
+          <a:bodyPr wrap="square" anchor="t">
+            <a:spAutoFit/>
+          </a:bodyPr>
+          <a:lstStyle/>
+          <a:p>
+            <a:pPr algn="l">
+              <a:lnSpc>
+                <a:spcPct val="100000"/>
+              </a:lnSpc>
+            </a:pPr>
+            <a:r>
+              <a:rPr sz="1000" b="0">
+                <a:solidFill>
+                  <a:srgbClr val="5A6474"/>
+                </a:solidFill>
+                <a:latin typeface="Courier New"/>
+              </a:rPr>
+              <a:t>Good Code, Good Vibes · TECHIE 1121 · Cornell Tech · Summer 2026</a:t>
+            </a:r>
+          </a:p>
+        </p:txBody>
+      </p:sp>
+    </p:spTree>
+  </p:cSld>
+  <p:clrMapOvr>
+    <a:masterClrMapping/>
+  </p:clrMapOvr>
+</p:sld>
+</file>
+
+<file path=ppt/slides/slide3.xml><?xml version="1.0" encoding="utf-8"?>
+<p:sld xmlns:a="http://schemas.openxmlformats.org/drawingml/2006/main" xmlns:p="http://schemas.openxmlformats.org/presentationml/2006/main" xmlns:r="http://schemas.openxmlformats.org/officeDocument/2006/relationships">
+  <p:cSld>
+    <p:bg>
+      <p:bgPr>
+        <a:solidFill>
+          <a:srgbClr val="0B0E14"/>
+        </a:solidFill>
+        <a:effectLst/>
+      </p:bgPr>
+    </p:bg>
+    <p:spTree>
+      <p:nvGrpSpPr>
+        <p:cNvPr id="1" name=""/>
+        <p:cNvGrpSpPr/>
+        <p:nvPr/>
+      </p:nvGrpSpPr>
+      <p:grpSpPr/>
+      <p:sp>
+        <p:nvSpPr>
+          <p:cNvPr id="2" name="TextBox 1"/>
+          <p:cNvSpPr txBox="1"/>
+          <p:nvPr/>
+        </p:nvSpPr>
+        <p:spPr>
+          <a:xfrm>
+            <a:off x="640080" y="502920"/>
+            <a:ext cx="10058400" cy="365760"/>
+          </a:xfrm>
+          <a:prstGeom prst="rect">
+            <a:avLst/>
+          </a:prstGeom>
+          <a:noFill/>
+        </p:spPr>
+        <p:txBody>
+          <a:bodyPr wrap="square" anchor="t">
+            <a:spAutoFit/>
+          </a:bodyPr>
+          <a:lstStyle/>
+          <a:p>
+            <a:pPr algn="l">
+              <a:lnSpc>
+                <a:spcPct val="100000"/>
+              </a:lnSpc>
+            </a:pPr>
+            <a:r>
+              <a:rPr sz="1300" b="1">
+                <a:solidFill>
+                  <a:srgbClr val="00FF41"/>
+                </a:solidFill>
+                <a:latin typeface="Courier New"/>
+              </a:rPr>
+              <a:t>THE TRAP</a:t>
+            </a:r>
+          </a:p>
+        </p:txBody>
+      </p:sp>
+      <p:sp>
+        <p:nvSpPr>
+          <p:cNvPr id="3" name="TextBox 2"/>
+          <p:cNvSpPr txBox="1"/>
+          <p:nvPr/>
+        </p:nvSpPr>
+        <p:spPr>
+          <a:xfrm>
+            <a:off x="1097280" y="548640"/>
+            <a:ext cx="2743200" cy="1828800"/>
+          </a:xfrm>
+          <a:prstGeom prst="rect">
+            <a:avLst/>
+          </a:prstGeom>
+          <a:noFill/>
+        </p:spPr>
+        <p:txBody>
+          <a:bodyPr wrap="square" anchor="t">
+            <a:spAutoFit/>
+          </a:bodyPr>
+          <a:lstStyle/>
+          <a:p>
+            <a:pPr algn="l">
+              <a:lnSpc>
+                <a:spcPct val="100000"/>
+              </a:lnSpc>
+            </a:pPr>
+            <a:r>
+              <a:rPr sz="12000" b="1">
+                <a:solidFill>
+                  <a:srgbClr val="00FF41"/>
+                </a:solidFill>
+                <a:latin typeface="Arial"/>
+              </a:rPr>
+              <a:t>?</a:t>
+            </a:r>
+          </a:p>
+        </p:txBody>
+      </p:sp>
+      <p:sp>
+        <p:nvSpPr>
+          <p:cNvPr id="4" name="TextBox 3"/>
+          <p:cNvSpPr txBox="1"/>
+          <p:nvPr/>
+        </p:nvSpPr>
+        <p:spPr>
+          <a:xfrm>
+            <a:off x="1097280" y="2743200"/>
+            <a:ext cx="10058400" cy="3108960"/>
+          </a:xfrm>
+          <a:prstGeom prst="rect">
+            <a:avLst/>
+          </a:prstGeom>
+          <a:noFill/>
+        </p:spPr>
+        <p:txBody>
+          <a:bodyPr wrap="square" anchor="t">
+            <a:spAutoFit/>
+          </a:bodyPr>
+          <a:lstStyle/>
+          <a:p>
+            <a:pPr algn="l">
+              <a:lnSpc>
+                <a:spcPct val="112000"/>
+              </a:lnSpc>
+            </a:pPr>
+            <a:r>
+              <a:rPr sz="3000" b="1">
+                <a:solidFill>
+                  <a:srgbClr val="F5F7FA"/>
+                </a:solidFill>
+                <a:latin typeface="Arial"/>
+              </a:rPr>
+              <a:t>How do you know you're building the RIGHT thing —</a:t>
+            </a:r>
+          </a:p>
+          <a:p>
+            <a:pPr algn="l">
+              <a:lnSpc>
+                <a:spcPct val="112000"/>
+              </a:lnSpc>
+            </a:pPr>
+            <a:r>
+              <a:rPr sz="3000" b="1">
+                <a:solidFill>
+                  <a:srgbClr val="F5F7FA"/>
+                </a:solidFill>
+                <a:latin typeface="Arial"/>
+              </a:rPr>
+              <a:t>before you've spent hours building it?</a:t>
+            </a:r>
+          </a:p>
+        </p:txBody>
+      </p:sp>
+      <p:sp>
+        <p:nvSpPr>
+          <p:cNvPr id="5" name="TextBox 4"/>
+          <p:cNvSpPr txBox="1"/>
+          <p:nvPr/>
+        </p:nvSpPr>
+        <p:spPr>
+          <a:xfrm>
+            <a:off x="640080" y="6355080"/>
+            <a:ext cx="10972800" cy="365760"/>
+          </a:xfrm>
+          <a:prstGeom prst="rect">
+            <a:avLst/>
+          </a:prstGeom>
+          <a:noFill/>
+        </p:spPr>
+        <p:txBody>
+          <a:bodyPr wrap="square" anchor="t">
+            <a:spAutoFit/>
+          </a:bodyPr>
+          <a:lstStyle/>
+          <a:p>
+            <a:pPr algn="l">
+              <a:lnSpc>
+                <a:spcPct val="100000"/>
+              </a:lnSpc>
+            </a:pPr>
+            <a:r>
+              <a:rPr sz="1000" b="0">
+                <a:solidFill>
+                  <a:srgbClr val="5A6474"/>
+                </a:solidFill>
+                <a:latin typeface="Courier New"/>
+              </a:rPr>
+              <a:t>Good Code, Good Vibes · TECHIE 1121 · Cornell Tech · Summer 2026</a:t>
+            </a:r>
+          </a:p>
+        </p:txBody>
+      </p:sp>
+    </p:spTree>
+  </p:cSld>
+  <p:clrMapOvr>
+    <a:masterClrMapping/>
+  </p:clrMapOvr>
+</p:sld>
+</file>
+
+<file path=ppt/slides/slide4.xml><?xml version="1.0" encoding="utf-8"?>
+<p:sld xmlns:a="http://schemas.openxmlformats.org/drawingml/2006/main" xmlns:p="http://schemas.openxmlformats.org/presentationml/2006/main" xmlns:r="http://schemas.openxmlformats.org/officeDocument/2006/relationships">
+  <p:cSld>
+    <p:bg>
+      <p:bgPr>
+        <a:solidFill>
+          <a:srgbClr val="0B0E14"/>
+        </a:solidFill>
+        <a:effectLst/>
+      </p:bgPr>
+    </p:bg>
+    <p:spTree>
+      <p:nvGrpSpPr>
+        <p:cNvPr id="1" name=""/>
+        <p:cNvGrpSpPr/>
+        <p:nvPr/>
+      </p:nvGrpSpPr>
+      <p:grpSpPr/>
+      <p:sp>
+        <p:nvSpPr>
+          <p:cNvPr id="2" name="TextBox 1"/>
+          <p:cNvSpPr txBox="1"/>
+          <p:nvPr/>
+        </p:nvSpPr>
+        <p:spPr>
+          <a:xfrm>
+            <a:off x="640080" y="502920"/>
+            <a:ext cx="10058400" cy="365760"/>
+          </a:xfrm>
+          <a:prstGeom prst="rect">
+            <a:avLst/>
+          </a:prstGeom>
+          <a:noFill/>
+        </p:spPr>
+        <p:txBody>
+          <a:bodyPr wrap="square" anchor="t">
+            <a:spAutoFit/>
+          </a:bodyPr>
+          <a:lstStyle/>
+          <a:p>
+            <a:pPr algn="l">
+              <a:lnSpc>
+                <a:spcPct val="100000"/>
+              </a:lnSpc>
+            </a:pPr>
+            <a:r>
+              <a:rPr sz="1300" b="1">
+                <a:solidFill>
+                  <a:srgbClr val="00FF41"/>
+                </a:solidFill>
+                <a:latin typeface="Courier New"/>
+              </a:rPr>
+              <a:t>DESIGN THINKING</a:t>
+            </a:r>
+          </a:p>
+        </p:txBody>
+      </p:sp>
+      <p:sp>
+        <p:nvSpPr>
+          <p:cNvPr id="3" name="Rectangle 2"/>
+          <p:cNvSpPr/>
+          <p:nvPr/>
+        </p:nvSpPr>
+        <p:spPr>
+          <a:xfrm>
+            <a:off x="640080" y="932688"/>
+            <a:ext cx="822960" cy="73152"/>
+          </a:xfrm>
+          <a:prstGeom prst="rect">
+            <a:avLst/>
+          </a:prstGeom>
+          <a:solidFill>
+            <a:srgbClr val="00FF41"/>
+          </a:solidFill>
+          <a:ln>
+            <a:noFill/>
+          </a:ln>
+          <a:effectLst/>
+        </p:spPr>
+        <p:style>
+          <a:lnRef idx="1">
+            <a:schemeClr val="accent1"/>
+          </a:lnRef>
+          <a:fillRef idx="3">
+            <a:schemeClr val="accent1"/>
+          </a:fillRef>
+          <a:effectRef idx="2">
+            <a:schemeClr val="accent1"/>
+          </a:effectRef>
+          <a:fontRef idx="minor">
+            <a:schemeClr val="lt1"/>
+          </a:fontRef>
+        </p:style>
+        <p:txBody>
+          <a:bodyPr rtlCol="0" anchor="ctr"/>
+          <a:lstStyle/>
+          <a:p>
+            <a:pPr algn="ctr"/>
+          </a:p>
+        </p:txBody>
+      </p:sp>
+      <p:sp>
+        <p:nvSpPr>
+          <p:cNvPr id="4" name="TextBox 3"/>
+          <p:cNvSpPr txBox="1"/>
+          <p:nvPr/>
+        </p:nvSpPr>
+        <p:spPr>
+          <a:xfrm>
+            <a:off x="640080" y="1051560"/>
+            <a:ext cx="10881360" cy="640080"/>
+          </a:xfrm>
+          <a:prstGeom prst="rect">
+            <a:avLst/>
+          </a:prstGeom>
+          <a:noFill/>
+        </p:spPr>
+        <p:txBody>
+          <a:bodyPr wrap="square" anchor="t">
+            <a:spAutoFit/>
+          </a:bodyPr>
+          <a:lstStyle/>
+          <a:p>
+            <a:pPr algn="l">
+              <a:lnSpc>
+                <a:spcPct val="100000"/>
+              </a:lnSpc>
+            </a:pPr>
+            <a:r>
+              <a:rPr sz="3400" b="1">
+                <a:solidFill>
+                  <a:srgbClr val="F5F7FA"/>
+                </a:solidFill>
+                <a:latin typeface="Arial"/>
+              </a:rPr>
+              <a:t>The Double Diamond — diverge, converge, twice</a:t>
+            </a:r>
+          </a:p>
+        </p:txBody>
+      </p:sp>
+      <p:sp>
+        <p:nvSpPr>
+          <p:cNvPr id="5" name="Diamond 4"/>
+          <p:cNvSpPr/>
+          <p:nvPr/>
+        </p:nvSpPr>
+        <p:spPr>
+          <a:xfrm>
+            <a:off x="1371600" y="2286000"/>
+            <a:ext cx="3840480" cy="2377440"/>
+          </a:xfrm>
+          <a:prstGeom prst="diamond">
+            <a:avLst/>
+          </a:prstGeom>
+          <a:solidFill>
+            <a:srgbClr val="151B26"/>
+          </a:solidFill>
+          <a:ln w="19050">
+            <a:solidFill>
+              <a:srgbClr val="00FF41"/>
+            </a:solidFill>
+          </a:ln>
+        </p:spPr>
+        <p:style>
+          <a:lnRef idx="1">
+            <a:schemeClr val="accent1"/>
+          </a:lnRef>
+          <a:fillRef idx="3">
+            <a:schemeClr val="accent1"/>
+          </a:fillRef>
+          <a:effectRef idx="2">
+            <a:schemeClr val="accent1"/>
+          </a:effectRef>
+          <a:fontRef idx="minor">
+            <a:schemeClr val="lt1"/>
+          </a:fontRef>
+        </p:style>
+        <p:txBody>
+          <a:bodyPr rtlCol="0" anchor="ctr"/>
+          <a:lstStyle/>
+          <a:p>
+            <a:pPr algn="ctr"/>
+          </a:p>
+        </p:txBody>
+      </p:sp>
+      <p:sp>
+        <p:nvSpPr>
+          <p:cNvPr id="6" name="TextBox 5"/>
+          <p:cNvSpPr txBox="1"/>
+          <p:nvPr/>
+        </p:nvSpPr>
+        <p:spPr>
+          <a:xfrm>
+            <a:off x="1371600" y="1874519"/>
+            <a:ext cx="3840480" cy="365760"/>
+          </a:xfrm>
+          <a:prstGeom prst="rect">
+            <a:avLst/>
+          </a:prstGeom>
+          <a:noFill/>
+        </p:spPr>
+        <p:txBody>
+          <a:bodyPr wrap="square" anchor="t">
+            <a:spAutoFit/>
+          </a:bodyPr>
+          <a:lstStyle/>
+          <a:p>
+            <a:pPr algn="ctr">
+              <a:lnSpc>
+                <a:spcPct val="100000"/>
+              </a:lnSpc>
+            </a:pPr>
+            <a:r>
+              <a:rPr sz="1300" b="1">
+                <a:solidFill>
+                  <a:srgbClr val="00FF41"/>
+                </a:solidFill>
+                <a:latin typeface="Courier New"/>
+              </a:rPr>
+              <a:t>PROBLEM SPACE</a:t>
+            </a:r>
+          </a:p>
+        </p:txBody>
+      </p:sp>
+      <p:sp>
+        <p:nvSpPr>
+          <p:cNvPr id="7" name="TextBox 6"/>
+          <p:cNvSpPr txBox="1"/>
+          <p:nvPr/>
+        </p:nvSpPr>
+        <p:spPr>
+          <a:xfrm>
+            <a:off x="1417321" y="3063240"/>
+            <a:ext cx="1828800" cy="822960"/>
+          </a:xfrm>
+          <a:prstGeom prst="rect">
+            <a:avLst/>
+          </a:prstGeom>
+          <a:noFill/>
+        </p:spPr>
+        <p:txBody>
+          <a:bodyPr wrap="square" anchor="t">
+            <a:spAutoFit/>
+          </a:bodyPr>
+          <a:lstStyle/>
+          <a:p>
+            <a:pPr algn="ctr">
+              <a:lnSpc>
+                <a:spcPct val="100000"/>
+              </a:lnSpc>
+            </a:pPr>
+            <a:r>
+              <a:rPr sz="1400" b="0">
+                <a:solidFill>
+                  <a:srgbClr val="F5F7FA"/>
+                </a:solidFill>
+                <a:latin typeface="Arial"/>
+              </a:rPr>
+              <a:t>Discover
+(diverge)</a:t>
+            </a:r>
+          </a:p>
+        </p:txBody>
+      </p:sp>
+      <p:sp>
+        <p:nvSpPr>
+          <p:cNvPr id="8" name="TextBox 7"/>
+          <p:cNvSpPr txBox="1"/>
+          <p:nvPr/>
+        </p:nvSpPr>
+        <p:spPr>
+          <a:xfrm>
+            <a:off x="3337560" y="3063240"/>
+            <a:ext cx="1828800" cy="822960"/>
+          </a:xfrm>
+          <a:prstGeom prst="rect">
+            <a:avLst/>
+          </a:prstGeom>
+          <a:noFill/>
+        </p:spPr>
+        <p:txBody>
+          <a:bodyPr wrap="square" anchor="t">
+            <a:spAutoFit/>
+          </a:bodyPr>
+          <a:lstStyle/>
+          <a:p>
+            <a:pPr algn="ctr">
+              <a:lnSpc>
+                <a:spcPct val="100000"/>
+              </a:lnSpc>
+            </a:pPr>
+            <a:r>
+              <a:rPr sz="1400" b="0">
+                <a:solidFill>
+                  <a:srgbClr val="F5F7FA"/>
+                </a:solidFill>
+                <a:latin typeface="Arial"/>
+              </a:rPr>
+              <a:t>Define
+(converge)</a:t>
+            </a:r>
+          </a:p>
+        </p:txBody>
+      </p:sp>
+      <p:sp>
+        <p:nvSpPr>
+          <p:cNvPr id="9" name="Diamond 8"/>
+          <p:cNvSpPr/>
+          <p:nvPr/>
+        </p:nvSpPr>
+        <p:spPr>
+          <a:xfrm>
+            <a:off x="6309360" y="2286000"/>
+            <a:ext cx="3840480" cy="2377440"/>
+          </a:xfrm>
+          <a:prstGeom prst="diamond">
+            <a:avLst/>
+          </a:prstGeom>
+          <a:solidFill>
+            <a:srgbClr val="151B26"/>
+          </a:solidFill>
+          <a:ln w="19050">
+            <a:solidFill>
+              <a:srgbClr val="00FF41"/>
+            </a:solidFill>
+          </a:ln>
+        </p:spPr>
+        <p:style>
+          <a:lnRef idx="1">
+            <a:schemeClr val="accent1"/>
+          </a:lnRef>
+          <a:fillRef idx="3">
+            <a:schemeClr val="accent1"/>
+          </a:fillRef>
+          <a:effectRef idx="2">
+            <a:schemeClr val="accent1"/>
+          </a:effectRef>
+          <a:fontRef idx="minor">
+            <a:schemeClr val="lt1"/>
+          </a:fontRef>
+        </p:style>
+        <p:txBody>
+          <a:bodyPr rtlCol="0" anchor="ctr"/>
+          <a:lstStyle/>
+          <a:p>
+            <a:pPr algn="ctr"/>
+          </a:p>
+        </p:txBody>
+      </p:sp>
+      <p:sp>
+        <p:nvSpPr>
+          <p:cNvPr id="10" name="TextBox 9"/>
+          <p:cNvSpPr txBox="1"/>
+          <p:nvPr/>
+        </p:nvSpPr>
+        <p:spPr>
+          <a:xfrm>
+            <a:off x="6309360" y="1874519"/>
+            <a:ext cx="3840480" cy="365760"/>
+          </a:xfrm>
+          <a:prstGeom prst="rect">
+            <a:avLst/>
+          </a:prstGeom>
+          <a:noFill/>
+        </p:spPr>
+        <p:txBody>
+          <a:bodyPr wrap="square" anchor="t">
+            <a:spAutoFit/>
+          </a:bodyPr>
+          <a:lstStyle/>
+          <a:p>
+            <a:pPr algn="ctr">
+              <a:lnSpc>
+                <a:spcPct val="100000"/>
+              </a:lnSpc>
+            </a:pPr>
+            <a:r>
+              <a:rPr sz="1300" b="1">
+                <a:solidFill>
+                  <a:srgbClr val="00FF41"/>
+                </a:solidFill>
+                <a:latin typeface="Courier New"/>
+              </a:rPr>
+              <a:t>SOLUTION SPACE</a:t>
+            </a:r>
+          </a:p>
+        </p:txBody>
+      </p:sp>
+      <p:sp>
+        <p:nvSpPr>
+          <p:cNvPr id="11" name="TextBox 10"/>
+          <p:cNvSpPr txBox="1"/>
+          <p:nvPr/>
+        </p:nvSpPr>
+        <p:spPr>
+          <a:xfrm>
+            <a:off x="6355081" y="3063240"/>
+            <a:ext cx="1828800" cy="822960"/>
+          </a:xfrm>
+          <a:prstGeom prst="rect">
+            <a:avLst/>
+          </a:prstGeom>
+          <a:noFill/>
+        </p:spPr>
+        <p:txBody>
+          <a:bodyPr wrap="square" anchor="t">
+            <a:spAutoFit/>
+          </a:bodyPr>
+          <a:lstStyle/>
+          <a:p>
+            <a:pPr algn="ctr">
+              <a:lnSpc>
+                <a:spcPct val="100000"/>
+              </a:lnSpc>
+            </a:pPr>
+            <a:r>
+              <a:rPr sz="1400" b="0">
+                <a:solidFill>
+                  <a:srgbClr val="F5F7FA"/>
+                </a:solidFill>
+                <a:latin typeface="Arial"/>
+              </a:rPr>
+              <a:t>Develop
+(diverge)</a:t>
+            </a:r>
+          </a:p>
+        </p:txBody>
+      </p:sp>
+      <p:sp>
+        <p:nvSpPr>
+          <p:cNvPr id="12" name="TextBox 11"/>
+          <p:cNvSpPr txBox="1"/>
+          <p:nvPr/>
+        </p:nvSpPr>
+        <p:spPr>
+          <a:xfrm>
+            <a:off x="8275320" y="3063240"/>
+            <a:ext cx="1828800" cy="822960"/>
+          </a:xfrm>
+          <a:prstGeom prst="rect">
+            <a:avLst/>
+          </a:prstGeom>
+          <a:noFill/>
+        </p:spPr>
+        <p:txBody>
+          <a:bodyPr wrap="square" anchor="t">
+            <a:spAutoFit/>
+          </a:bodyPr>
+          <a:lstStyle/>
+          <a:p>
+            <a:pPr algn="ctr">
+              <a:lnSpc>
+                <a:spcPct val="100000"/>
+              </a:lnSpc>
+            </a:pPr>
+            <a:r>
+              <a:rPr sz="1400" b="0">
+                <a:solidFill>
+                  <a:srgbClr val="F5F7FA"/>
+                </a:solidFill>
+                <a:latin typeface="Arial"/>
+              </a:rPr>
+              <a:t>Deliver
+(converge)</a:t>
+            </a:r>
+          </a:p>
+        </p:txBody>
+      </p:sp>
+      <p:sp>
+        <p:nvSpPr>
+          <p:cNvPr id="13" name="Rounded Rectangle 12"/>
+          <p:cNvSpPr/>
+          <p:nvPr/>
+        </p:nvSpPr>
+        <p:spPr>
+          <a:xfrm>
+            <a:off x="5349240" y="2606040"/>
+            <a:ext cx="822960" cy="1737360"/>
+          </a:xfrm>
+          <a:prstGeom prst="roundRect">
+            <a:avLst/>
+          </a:prstGeom>
+          <a:solidFill>
+            <a:srgbClr val="0B0E14"/>
+          </a:solidFill>
+          <a:ln w="25400">
+            <a:solidFill>
+              <a:srgbClr val="00FF41"/>
+            </a:solidFill>
+            <a:prstDash val="dash"/>
+          </a:ln>
+          <a:effectLst/>
+        </p:spPr>
+        <p:style>
+          <a:lnRef idx="1">
+            <a:schemeClr val="accent1"/>
+          </a:lnRef>
+          <a:fillRef idx="3">
+            <a:schemeClr val="accent1"/>
+          </a:fillRef>
+          <a:effectRef idx="2">
+            <a:schemeClr val="accent1"/>
+          </a:effectRef>
+          <a:fontRef idx="minor">
+            <a:schemeClr val="lt1"/>
+          </a:fontRef>
+        </p:style>
+        <p:txBody>
+          <a:bodyPr rtlCol="0" anchor="ctr"/>
+          <a:lstStyle/>
+          <a:p>
+            <a:pPr algn="ctr"/>
+          </a:p>
+        </p:txBody>
+      </p:sp>
+      <p:sp>
+        <p:nvSpPr>
+          <p:cNvPr id="14" name="TextBox 13"/>
+          <p:cNvSpPr txBox="1"/>
+          <p:nvPr/>
+        </p:nvSpPr>
+        <p:spPr>
+          <a:xfrm>
+            <a:off x="4434840" y="4480560"/>
+            <a:ext cx="2651760" cy="731520"/>
+          </a:xfrm>
+          <a:prstGeom prst="rect">
+            <a:avLst/>
+          </a:prstGeom>
+          <a:noFill/>
+        </p:spPr>
+        <p:txBody>
+          <a:bodyPr wrap="square" anchor="t">
+            <a:spAutoFit/>
+          </a:bodyPr>
+          <a:lstStyle/>
+          <a:p>
+            <a:pPr algn="ctr">
+              <a:lnSpc>
+                <a:spcPct val="100000"/>
+              </a:lnSpc>
+            </a:pPr>
+            <a:r>
+              <a:rPr sz="1400" b="1">
+                <a:solidFill>
+                  <a:srgbClr val="00FF41"/>
+                </a:solidFill>
+                <a:latin typeface="Arial"/>
+              </a:rPr>
+              <a:t>the fake-it test
+lives HERE</a:t>
+            </a:r>
+          </a:p>
+        </p:txBody>
+      </p:sp>
+      <p:sp>
+        <p:nvSpPr>
+          <p:cNvPr id="15" name="TextBox 14"/>
+          <p:cNvSpPr txBox="1"/>
+          <p:nvPr/>
+        </p:nvSpPr>
+        <p:spPr>
+          <a:xfrm>
+            <a:off x="640080" y="5394960"/>
+            <a:ext cx="10881360" cy="914400"/>
+          </a:xfrm>
+          <a:prstGeom prst="rect">
+            <a:avLst/>
+          </a:prstGeom>
+          <a:noFill/>
+        </p:spPr>
+        <p:txBody>
+          <a:bodyPr wrap="square" anchor="t">
+            <a:spAutoFit/>
+          </a:bodyPr>
+          <a:lstStyle/>
+          <a:p>
+            <a:pPr algn="l">
+              <a:lnSpc>
+                <a:spcPct val="100000"/>
+              </a:lnSpc>
+            </a:pPr>
+            <a:r>
+              <a:rPr sz="1600" b="0">
+                <a:solidFill>
+                  <a:srgbClr val="8A94A6"/>
+                </a:solidFill>
+                <a:latin typeface="Arial"/>
+              </a:rPr>
+              <a:t>Brainstorm wide, then commit to one problem. Your Wizard-of-Oz test sits at the pinch: it's how you converge on the right problem before you diverge into building.</a:t>
+            </a:r>
+          </a:p>
+        </p:txBody>
+      </p:sp>
+      <p:sp>
+        <p:nvSpPr>
+          <p:cNvPr id="16" name="TextBox 15"/>
+          <p:cNvSpPr txBox="1"/>
+          <p:nvPr/>
+        </p:nvSpPr>
+        <p:spPr>
+          <a:xfrm>
+            <a:off x="640080" y="6355080"/>
+            <a:ext cx="10972800" cy="365760"/>
+          </a:xfrm>
+          <a:prstGeom prst="rect">
+            <a:avLst/>
+          </a:prstGeom>
+          <a:noFill/>
+        </p:spPr>
+        <p:txBody>
+          <a:bodyPr wrap="square" anchor="t">
+            <a:spAutoFit/>
+          </a:bodyPr>
+          <a:lstStyle/>
+          <a:p>
+            <a:pPr algn="l">
+              <a:lnSpc>
+                <a:spcPct val="100000"/>
+              </a:lnSpc>
+            </a:pPr>
+            <a:r>
+              <a:rPr sz="1000" b="0">
+                <a:solidFill>
+                  <a:srgbClr val="5A6474"/>
+                </a:solidFill>
+                <a:latin typeface="Courier New"/>
+              </a:rPr>
+              <a:t>Good Code, Good Vibes · TECHIE 1121 · Cornell Tech · Summer 2026</a:t>
+            </a:r>
+          </a:p>
+        </p:txBody>
+      </p:sp>
+    </p:spTree>
+  </p:cSld>
+  <p:clrMapOvr>
+    <a:masterClrMapping/>
+  </p:clrMapOvr>
+</p:sld>
+</file>
+
+<file path=ppt/slides/slide5.xml><?xml version="1.0" encoding="utf-8"?>
+<p:sld xmlns:a="http://schemas.openxmlformats.org/drawingml/2006/main" xmlns:p="http://schemas.openxmlformats.org/presentationml/2006/main" xmlns:r="http://schemas.openxmlformats.org/officeDocument/2006/relationships">
+  <p:cSld>
+    <p:bg>
+      <p:bgPr>
+        <a:solidFill>
+          <a:srgbClr val="0B0E14"/>
+        </a:solidFill>
+        <a:effectLst/>
+      </p:bgPr>
+    </p:bg>
+    <p:spTree>
+      <p:nvGrpSpPr>
+        <p:cNvPr id="1" name=""/>
+        <p:cNvGrpSpPr/>
+        <p:nvPr/>
+      </p:nvGrpSpPr>
+      <p:grpSpPr/>
+      <p:sp>
+        <p:nvSpPr>
+          <p:cNvPr id="2" name="TextBox 1"/>
+          <p:cNvSpPr txBox="1"/>
+          <p:nvPr/>
+        </p:nvSpPr>
+        <p:spPr>
+          <a:xfrm>
+            <a:off x="640080" y="502920"/>
+            <a:ext cx="10058400" cy="365760"/>
+          </a:xfrm>
+          <a:prstGeom prst="rect">
+            <a:avLst/>
+          </a:prstGeom>
+          <a:noFill/>
+        </p:spPr>
+        <p:txBody>
+          <a:bodyPr wrap="square" anchor="t">
+            <a:spAutoFit/>
+          </a:bodyPr>
+          <a:lstStyle/>
+          <a:p>
+            <a:pPr algn="l">
+              <a:lnSpc>
+                <a:spcPct val="100000"/>
+              </a:lnSpc>
+            </a:pPr>
+            <a:r>
+              <a:rPr sz="1300" b="1">
+                <a:solidFill>
+                  <a:srgbClr val="00FF41"/>
+                </a:solidFill>
+                <a:latin typeface="Courier New"/>
+              </a:rPr>
+              <a:t>METHOD</a:t>
+            </a:r>
+          </a:p>
+        </p:txBody>
+      </p:sp>
+      <p:sp>
+        <p:nvSpPr>
+          <p:cNvPr id="3" name="Rectangle 2"/>
+          <p:cNvSpPr/>
+          <p:nvPr/>
+        </p:nvSpPr>
+        <p:spPr>
+          <a:xfrm>
+            <a:off x="640080" y="932688"/>
+            <a:ext cx="822960" cy="73152"/>
+          </a:xfrm>
+          <a:prstGeom prst="rect">
+            <a:avLst/>
+          </a:prstGeom>
+          <a:solidFill>
+            <a:srgbClr val="00FF41"/>
+          </a:solidFill>
+          <a:ln>
+            <a:noFill/>
+          </a:ln>
+          <a:effectLst/>
+        </p:spPr>
+        <p:style>
+          <a:lnRef idx="1">
+            <a:schemeClr val="accent1"/>
+          </a:lnRef>
+          <a:fillRef idx="3">
+            <a:schemeClr val="accent1"/>
+          </a:fillRef>
+          <a:effectRef idx="2">
+            <a:schemeClr val="accent1"/>
+          </a:effectRef>
+          <a:fontRef idx="minor">
+            <a:schemeClr val="lt1"/>
+          </a:fontRef>
+        </p:style>
+        <p:txBody>
+          <a:bodyPr rtlCol="0" anchor="ctr"/>
+          <a:lstStyle/>
+          <a:p>
+            <a:pPr algn="ctr"/>
+          </a:p>
+        </p:txBody>
+      </p:sp>
+      <p:sp>
+        <p:nvSpPr>
+          <p:cNvPr id="4" name="TextBox 3"/>
+          <p:cNvSpPr txBox="1"/>
+          <p:nvPr/>
+        </p:nvSpPr>
+        <p:spPr>
+          <a:xfrm>
+            <a:off x="640080" y="1188720"/>
+            <a:ext cx="10972800" cy="1097280"/>
+          </a:xfrm>
+          <a:prstGeom prst="rect">
+            <a:avLst/>
+          </a:prstGeom>
+          <a:noFill/>
+        </p:spPr>
+        <p:txBody>
+          <a:bodyPr wrap="square" anchor="t">
+            <a:spAutoFit/>
+          </a:bodyPr>
+          <a:lstStyle/>
+          <a:p>
+            <a:pPr algn="l">
+              <a:lnSpc>
+                <a:spcPct val="100000"/>
+              </a:lnSpc>
+            </a:pPr>
+            <a:r>
+              <a:rPr sz="3400" b="1">
+                <a:solidFill>
+                  <a:srgbClr val="F5F7FA"/>
+                </a:solidFill>
+                <a:latin typeface="Arial"/>
+              </a:rPr>
+              <a:t>Wizard of Oz — the human behind the curtain</a:t>
+            </a:r>
+          </a:p>
+        </p:txBody>
+      </p:sp>
+      <p:sp>
+        <p:nvSpPr>
+          <p:cNvPr id="5" name="TextBox 4"/>
+          <p:cNvSpPr txBox="1"/>
+          <p:nvPr/>
+        </p:nvSpPr>
+        <p:spPr>
+          <a:xfrm>
+            <a:off x="658368" y="2286000"/>
+            <a:ext cx="10881360" cy="3657600"/>
+          </a:xfrm>
+          <a:prstGeom prst="rect">
+            <a:avLst/>
+          </a:prstGeom>
+          <a:noFill/>
+        </p:spPr>
+        <p:txBody>
+          <a:bodyPr wrap="square" anchor="t">
+            <a:spAutoFit/>
+          </a:bodyPr>
+          <a:lstStyle/>
+          <a:p>
+            <a:pPr algn="l">
+              <a:lnSpc>
+                <a:spcPct val="112000"/>
+              </a:lnSpc>
+            </a:pPr>
+            <a:r>
+              <a:rPr sz="2000" b="0">
+                <a:solidFill>
+                  <a:srgbClr val="F5F7FA"/>
+                </a:solidFill>
+                <a:latin typeface="Arial"/>
+              </a:rPr>
+              <a:t>A classic HCI method: the user interacts with what looks like a working system — but a hidden human is playing the machine.</a:t>
+            </a:r>
+          </a:p>
+          <a:p>
+            <a:pPr algn="l">
+              <a:lnSpc>
+                <a:spcPct val="112000"/>
+              </a:lnSpc>
+            </a:pPr>
+            <a:r>
+              <a:rPr sz="2000" b="0">
+                <a:solidFill>
+                  <a:srgbClr val="F5F7FA"/>
+                </a:solidFill>
+                <a:latin typeface="Arial"/>
+              </a:rPr>
+              <a:t>Named for the man behind the curtain; used since the 1980s to test systems that would be expensive to build (early speech interfaces were 'recognized' by a typist next door).</a:t>
+            </a:r>
+          </a:p>
+          <a:p>
+            <a:pPr algn="l">
+              <a:lnSpc>
+                <a:spcPct val="112000"/>
+              </a:lnSpc>
+            </a:pPr>
+            <a:r>
+              <a:rPr sz="2000" b="0">
+                <a:solidFill>
+                  <a:srgbClr val="F5F7FA"/>
+                </a:solidFill>
+                <a:latin typeface="Arial"/>
+              </a:rPr>
+              <a:t>The point: you can test the EXPERIENCE before you've built the ENGINEERING.</a:t>
+            </a:r>
+          </a:p>
+          <a:p>
+            <a:pPr algn="l">
+              <a:lnSpc>
+                <a:spcPct val="112000"/>
+              </a:lnSpc>
+            </a:pPr>
+            <a:r>
+              <a:rPr sz="2000" b="0">
+                <a:solidFill>
+                  <a:srgbClr val="F5F7FA"/>
+                </a:solidFill>
+                <a:latin typeface="Arial"/>
+              </a:rPr>
+              <a:t>If the experience fails with a perfect human playing the system, no amount of code will save it.</a:t>
+            </a:r>
+          </a:p>
+        </p:txBody>
+      </p:sp>
+      <p:sp>
+        <p:nvSpPr>
+          <p:cNvPr id="6" name="TextBox 5"/>
+          <p:cNvSpPr txBox="1"/>
+          <p:nvPr/>
+        </p:nvSpPr>
+        <p:spPr>
+          <a:xfrm>
+            <a:off x="640080" y="6355080"/>
+            <a:ext cx="10972800" cy="365760"/>
+          </a:xfrm>
+          <a:prstGeom prst="rect">
+            <a:avLst/>
+          </a:prstGeom>
+          <a:noFill/>
+        </p:spPr>
+        <p:txBody>
+          <a:bodyPr wrap="square" anchor="t">
+            <a:spAutoFit/>
+          </a:bodyPr>
+          <a:lstStyle/>
+          <a:p>
+            <a:pPr algn="l">
+              <a:lnSpc>
+                <a:spcPct val="100000"/>
+              </a:lnSpc>
+            </a:pPr>
+            <a:r>
+              <a:rPr sz="1000" b="0">
+                <a:solidFill>
+                  <a:srgbClr val="5A6474"/>
+                </a:solidFill>
+                <a:latin typeface="Courier New"/>
+              </a:rPr>
+              <a:t>Good Code, Good Vibes · TECHIE 1121 · Cornell Tech · Summer 2026</a:t>
+            </a:r>
+          </a:p>
+        </p:txBody>
+      </p:sp>
+    </p:spTree>
+  </p:cSld>
+  <p:clrMapOvr>
+    <a:masterClrMapping/>
+  </p:clrMapOvr>
+</p:sld>
+</file>
+
+<file path=ppt/slides/slide6.xml><?xml version="1.0" encoding="utf-8"?>
+<p:sld xmlns:a="http://schemas.openxmlformats.org/drawingml/2006/main" xmlns:p="http://schemas.openxmlformats.org/presentationml/2006/main" xmlns:r="http://schemas.openxmlformats.org/officeDocument/2006/relationships">
+  <p:cSld>
+    <p:bg>
+      <p:bgPr>
+        <a:solidFill>
+          <a:srgbClr val="0B0E14"/>
+        </a:solidFill>
+        <a:effectLst/>
+      </p:bgPr>
+    </p:bg>
+    <p:spTree>
+      <p:nvGrpSpPr>
+        <p:cNvPr id="1" name=""/>
+        <p:cNvGrpSpPr/>
+        <p:nvPr/>
+      </p:nvGrpSpPr>
+      <p:grpSpPr/>
+      <p:sp>
+        <p:nvSpPr>
+          <p:cNvPr id="2" name="TextBox 1"/>
+          <p:cNvSpPr txBox="1"/>
+          <p:nvPr/>
+        </p:nvSpPr>
+        <p:spPr>
+          <a:xfrm>
+            <a:off x="640080" y="502920"/>
+            <a:ext cx="10058400" cy="365760"/>
+          </a:xfrm>
+          <a:prstGeom prst="rect">
+            <a:avLst/>
+          </a:prstGeom>
+          <a:noFill/>
+        </p:spPr>
+        <p:txBody>
+          <a:bodyPr wrap="square" anchor="t">
+            <a:spAutoFit/>
+          </a:bodyPr>
+          <a:lstStyle/>
+          <a:p>
+            <a:pPr algn="l">
+              <a:lnSpc>
+                <a:spcPct val="100000"/>
+              </a:lnSpc>
+            </a:pPr>
+            <a:r>
+              <a:rPr sz="1300" b="1">
+                <a:solidFill>
+                  <a:srgbClr val="00FF41"/>
+                </a:solidFill>
+                <a:latin typeface="Courier New"/>
+              </a:rPr>
+              <a:t>READING</a:t>
+            </a:r>
+          </a:p>
+        </p:txBody>
+      </p:sp>
+      <p:sp>
+        <p:nvSpPr>
+          <p:cNvPr id="3" name="Rectangle 2"/>
+          <p:cNvSpPr/>
+          <p:nvPr/>
+        </p:nvSpPr>
+        <p:spPr>
+          <a:xfrm>
+            <a:off x="640080" y="932688"/>
+            <a:ext cx="822960" cy="73152"/>
+          </a:xfrm>
+          <a:prstGeom prst="rect">
+            <a:avLst/>
+          </a:prstGeom>
+          <a:solidFill>
+            <a:srgbClr val="00FF41"/>
+          </a:solidFill>
+          <a:ln>
+            <a:noFill/>
+          </a:ln>
+          <a:effectLst/>
+        </p:spPr>
+        <p:style>
+          <a:lnRef idx="1">
+            <a:schemeClr val="accent1"/>
+          </a:lnRef>
+          <a:fillRef idx="3">
+            <a:schemeClr val="accent1"/>
+          </a:fillRef>
+          <a:effectRef idx="2">
+            <a:schemeClr val="accent1"/>
+          </a:effectRef>
+          <a:fontRef idx="minor">
+            <a:schemeClr val="lt1"/>
+          </a:fontRef>
+        </p:style>
+        <p:txBody>
+          <a:bodyPr rtlCol="0" anchor="ctr"/>
+          <a:lstStyle/>
+          <a:p>
+            <a:pPr algn="ctr"/>
+          </a:p>
+        </p:txBody>
+      </p:sp>
+      <p:sp>
+        <p:nvSpPr>
+          <p:cNvPr id="4" name="TextBox 3"/>
+          <p:cNvSpPr txBox="1"/>
+          <p:nvPr/>
+        </p:nvSpPr>
+        <p:spPr>
+          <a:xfrm>
+            <a:off x="640080" y="1188720"/>
+            <a:ext cx="10972800" cy="1097280"/>
+          </a:xfrm>
+          <a:prstGeom prst="rect">
+            <a:avLst/>
+          </a:prstGeom>
+          <a:noFill/>
+        </p:spPr>
+        <p:txBody>
+          <a:bodyPr wrap="square" anchor="t">
+            <a:spAutoFit/>
+          </a:bodyPr>
+          <a:lstStyle/>
+          <a:p>
+            <a:pPr algn="l">
+              <a:lnSpc>
+                <a:spcPct val="100000"/>
+              </a:lnSpc>
+            </a:pPr>
+            <a:r>
+              <a:rPr sz="3400" b="1">
+                <a:solidFill>
+                  <a:srgbClr val="F5F7FA"/>
+                </a:solidFill>
+                <a:latin typeface="Arial"/>
+              </a:rPr>
+              <a:t>Fake It to Make It — prototyping as theater</a:t>
+            </a:r>
+          </a:p>
+        </p:txBody>
+      </p:sp>
+      <p:sp>
+        <p:nvSpPr>
+          <p:cNvPr id="5" name="TextBox 4"/>
+          <p:cNvSpPr txBox="1"/>
+          <p:nvPr/>
+        </p:nvSpPr>
+        <p:spPr>
+          <a:xfrm>
+            <a:off x="658368" y="2286000"/>
+            <a:ext cx="10881360" cy="3657600"/>
+          </a:xfrm>
+          <a:prstGeom prst="rect">
+            <a:avLst/>
+          </a:prstGeom>
+          <a:noFill/>
+        </p:spPr>
+        <p:txBody>
+          <a:bodyPr wrap="square" anchor="t">
+            <a:spAutoFit/>
+          </a:bodyPr>
+          <a:lstStyle/>
+          <a:p>
+            <a:pPr algn="l">
+              <a:lnSpc>
+                <a:spcPct val="112000"/>
+              </a:lnSpc>
+            </a:pPr>
+            <a:r>
+              <a:rPr sz="2000" b="0">
+                <a:solidFill>
+                  <a:srgbClr val="F5F7FA"/>
+                </a:solidFill>
+                <a:latin typeface="Arial"/>
+              </a:rPr>
+              <a:t>Zamfirescu-Pereira et al., HRI '21 — same first author as Tuesday's 'Why Johnny Can't Prompt', co-authored at Cornell Tech (yes, that Wendy Ju).</a:t>
+            </a:r>
+          </a:p>
+          <a:p>
+            <a:pPr algn="l">
+              <a:lnSpc>
+                <a:spcPct val="112000"/>
+              </a:lnSpc>
+            </a:pPr>
+            <a:r>
+              <a:rPr sz="2000" b="0">
+                <a:solidFill>
+                  <a:srgbClr val="F5F7FA"/>
+                </a:solidFill>
+                <a:latin typeface="Arial"/>
+              </a:rPr>
+              <a:t>Exploratory prototyping: act out the parts of the system that don't exist — with bodies, props, sticky notes — to learn whether it's worth building at all.</a:t>
+            </a:r>
+          </a:p>
+          <a:p>
+            <a:pPr algn="l">
+              <a:lnSpc>
+                <a:spcPct val="112000"/>
+              </a:lnSpc>
+            </a:pPr>
+            <a:r>
+              <a:rPr sz="2000" b="0">
+                <a:solidFill>
+                  <a:srgbClr val="F5F7FA"/>
+                </a:solidFill>
+                <a:latin typeface="Arial"/>
+              </a:rPr>
+              <a:t>Faking is not cheating. It's the cheapest possible probe of the riskiest question: does anyone want this, and does the flow make sense?</a:t>
+            </a:r>
+          </a:p>
+          <a:p>
+            <a:pPr algn="l">
+              <a:lnSpc>
+                <a:spcPct val="112000"/>
+              </a:lnSpc>
+            </a:pPr>
+            <a:r>
+              <a:rPr sz="2000" b="0">
+                <a:solidFill>
+                  <a:srgbClr val="F5F7FA"/>
+                </a:solidFill>
+                <a:latin typeface="Arial"/>
+              </a:rPr>
+              <a:t>Their domain is robots; yours is apps. The move is identical.</a:t>
+            </a:r>
+          </a:p>
+        </p:txBody>
+      </p:sp>
+      <p:sp>
+        <p:nvSpPr>
+          <p:cNvPr id="6" name="TextBox 5"/>
+          <p:cNvSpPr txBox="1"/>
+          <p:nvPr/>
+        </p:nvSpPr>
+        <p:spPr>
+          <a:xfrm>
+            <a:off x="640080" y="6355080"/>
+            <a:ext cx="10972800" cy="365760"/>
+          </a:xfrm>
+          <a:prstGeom prst="rect">
+            <a:avLst/>
+          </a:prstGeom>
+          <a:noFill/>
+        </p:spPr>
+        <p:txBody>
+          <a:bodyPr wrap="square" anchor="t">
+            <a:spAutoFit/>
+          </a:bodyPr>
+          <a:lstStyle/>
+          <a:p>
+            <a:pPr algn="l">
+              <a:lnSpc>
+                <a:spcPct val="100000"/>
+              </a:lnSpc>
+            </a:pPr>
+            <a:r>
+              <a:rPr sz="1000" b="0">
+                <a:solidFill>
+                  <a:srgbClr val="5A6474"/>
+                </a:solidFill>
+                <a:latin typeface="Courier New"/>
+              </a:rPr>
+              <a:t>Good Code, Good Vibes · TECHIE 1121 · Cornell Tech · Summer 2026</a:t>
+            </a:r>
+          </a:p>
+        </p:txBody>
+      </p:sp>
+    </p:spTree>
+  </p:cSld>
+  <p:clrMapOvr>
+    <a:masterClrMapping/>
+  </p:clrMapOvr>
+</p:sld>
+</file>
+
+<file path=ppt/slides/slide7.xml><?xml version="1.0" encoding="utf-8"?>
+<p:sld xmlns:a="http://schemas.openxmlformats.org/drawingml/2006/main" xmlns:p="http://schemas.openxmlformats.org/presentationml/2006/main" xmlns:r="http://schemas.openxmlformats.org/officeDocument/2006/relationships">
+  <p:cSld>
+    <p:bg>
+      <p:bgPr>
+        <a:solidFill>
+          <a:srgbClr val="0B0E14"/>
+        </a:solidFill>
+        <a:effectLst/>
+      </p:bgPr>
+    </p:bg>
+    <p:spTree>
+      <p:nvGrpSpPr>
+        <p:cNvPr id="1" name=""/>
+        <p:cNvGrpSpPr/>
+        <p:nvPr/>
+      </p:nvGrpSpPr>
+      <p:grpSpPr/>
+      <p:sp>
+        <p:nvSpPr>
+          <p:cNvPr id="2" name="TextBox 1"/>
+          <p:cNvSpPr txBox="1"/>
+          <p:nvPr/>
+        </p:nvSpPr>
+        <p:spPr>
+          <a:xfrm>
+            <a:off x="640080" y="502920"/>
+            <a:ext cx="10058400" cy="365760"/>
+          </a:xfrm>
+          <a:prstGeom prst="rect">
+            <a:avLst/>
+          </a:prstGeom>
+          <a:noFill/>
+        </p:spPr>
+        <p:txBody>
+          <a:bodyPr wrap="square" anchor="t">
+            <a:spAutoFit/>
+          </a:bodyPr>
+          <a:lstStyle/>
+          <a:p>
+            <a:pPr algn="l">
+              <a:lnSpc>
+                <a:spcPct val="100000"/>
+              </a:lnSpc>
+            </a:pPr>
+            <a:r>
+              <a:rPr sz="1300" b="1">
+                <a:solidFill>
+                  <a:srgbClr val="00FF41"/>
+                </a:solidFill>
+                <a:latin typeface="Courier New"/>
+              </a:rPr>
+              <a:t>AI + WOZ</a:t>
+            </a:r>
+          </a:p>
+        </p:txBody>
+      </p:sp>
+      <p:sp>
+        <p:nvSpPr>
+          <p:cNvPr id="3" name="Rectangle 2"/>
+          <p:cNvSpPr/>
+          <p:nvPr/>
+        </p:nvSpPr>
+        <p:spPr>
+          <a:xfrm>
+            <a:off x="640080" y="932688"/>
+            <a:ext cx="822960" cy="73152"/>
+          </a:xfrm>
+          <a:prstGeom prst="rect">
+            <a:avLst/>
+          </a:prstGeom>
+          <a:solidFill>
+            <a:srgbClr val="00FF41"/>
+          </a:solidFill>
+          <a:ln>
+            <a:noFill/>
+          </a:ln>
+          <a:effectLst/>
+        </p:spPr>
+        <p:style>
+          <a:lnRef idx="1">
+            <a:schemeClr val="accent1"/>
+          </a:lnRef>
+          <a:fillRef idx="3">
+            <a:schemeClr val="accent1"/>
+          </a:fillRef>
+          <a:effectRef idx="2">
+            <a:schemeClr val="accent1"/>
+          </a:effectRef>
+          <a:fontRef idx="minor">
+            <a:schemeClr val="lt1"/>
+          </a:fontRef>
+        </p:style>
+        <p:txBody>
+          <a:bodyPr rtlCol="0" anchor="ctr"/>
+          <a:lstStyle/>
+          <a:p>
+            <a:pPr algn="ctr"/>
+          </a:p>
+        </p:txBody>
+      </p:sp>
+      <p:sp>
+        <p:nvSpPr>
+          <p:cNvPr id="4" name="TextBox 3"/>
+          <p:cNvSpPr txBox="1"/>
+          <p:nvPr/>
+        </p:nvSpPr>
+        <p:spPr>
+          <a:xfrm>
+            <a:off x="640080" y="1188720"/>
+            <a:ext cx="10972800" cy="914400"/>
+          </a:xfrm>
+          <a:prstGeom prst="rect">
+            <a:avLst/>
+          </a:prstGeom>
+          <a:noFill/>
+        </p:spPr>
+        <p:txBody>
+          <a:bodyPr wrap="square" anchor="t">
+            <a:spAutoFit/>
+          </a:bodyPr>
+          <a:lstStyle/>
+          <a:p>
+            <a:pPr algn="l">
+              <a:lnSpc>
+                <a:spcPct val="100000"/>
+              </a:lnSpc>
+            </a:pPr>
+            <a:r>
+              <a:rPr sz="3200" b="1">
+                <a:solidFill>
+                  <a:srgbClr val="F5F7FA"/>
+                </a:solidFill>
+                <a:latin typeface="Arial"/>
+              </a:rPr>
+              <a:t>Partial Wizard of Oz — AI moved the curtain</a:t>
+            </a:r>
+          </a:p>
+        </p:txBody>
+      </p:sp>
+      <p:sp>
+        <p:nvSpPr>
+          <p:cNvPr id="5" name="Rounded Rectangle 4"/>
+          <p:cNvSpPr/>
+          <p:nvPr/>
+        </p:nvSpPr>
+        <p:spPr>
+          <a:xfrm>
+            <a:off x="640080" y="2468880"/>
+            <a:ext cx="3393338" cy="3383280"/>
+          </a:xfrm>
+          <a:prstGeom prst="roundRect">
+            <a:avLst/>
+          </a:prstGeom>
+          <a:solidFill>
+            <a:srgbClr val="151B26"/>
+          </a:solidFill>
+          <a:ln>
+            <a:noFill/>
+          </a:ln>
+          <a:effectLst/>
+        </p:spPr>
+        <p:style>
+          <a:lnRef idx="1">
+            <a:schemeClr val="accent1"/>
+          </a:lnRef>
+          <a:fillRef idx="3">
+            <a:schemeClr val="accent1"/>
+          </a:fillRef>
+          <a:effectRef idx="2">
+            <a:schemeClr val="accent1"/>
+          </a:effectRef>
+          <a:fontRef idx="minor">
+            <a:schemeClr val="lt1"/>
+          </a:fontRef>
+        </p:style>
+        <p:txBody>
+          <a:bodyPr rtlCol="0" anchor="ctr"/>
+          <a:lstStyle/>
+          <a:p>
+            <a:pPr algn="ctr"/>
+          </a:p>
+        </p:txBody>
+      </p:sp>
+      <p:sp>
+        <p:nvSpPr>
+          <p:cNvPr id="6" name="Rectangle 5"/>
+          <p:cNvSpPr/>
+          <p:nvPr/>
+        </p:nvSpPr>
+        <p:spPr>
+          <a:xfrm>
+            <a:off x="640080" y="2468880"/>
+            <a:ext cx="3393338" cy="82296"/>
+          </a:xfrm>
+          <a:prstGeom prst="rect">
+            <a:avLst/>
+          </a:prstGeom>
+          <a:solidFill>
+            <a:srgbClr val="00FF41"/>
+          </a:solidFill>
+          <a:ln>
+            <a:noFill/>
+          </a:ln>
+          <a:effectLst/>
+        </p:spPr>
+        <p:style>
+          <a:lnRef idx="1">
+            <a:schemeClr val="accent1"/>
+          </a:lnRef>
+          <a:fillRef idx="3">
+            <a:schemeClr val="accent1"/>
+          </a:fillRef>
+          <a:effectRef idx="2">
+            <a:schemeClr val="accent1"/>
+          </a:effectRef>
+          <a:fontRef idx="minor">
+            <a:schemeClr val="lt1"/>
+          </a:fontRef>
+        </p:style>
+        <p:txBody>
+          <a:bodyPr rtlCol="0" anchor="ctr"/>
+          <a:lstStyle/>
+          <a:p>
+            <a:pPr algn="ctr"/>
+          </a:p>
+        </p:txBody>
+      </p:sp>
+      <p:sp>
+        <p:nvSpPr>
+          <p:cNvPr id="7" name="TextBox 6"/>
+          <p:cNvSpPr txBox="1"/>
+          <p:nvPr/>
+        </p:nvSpPr>
+        <p:spPr>
+          <a:xfrm>
+            <a:off x="914400" y="2788920"/>
+            <a:ext cx="2844698" cy="457200"/>
+          </a:xfrm>
+          <a:prstGeom prst="rect">
+            <a:avLst/>
+          </a:prstGeom>
+          <a:noFill/>
+        </p:spPr>
+        <p:txBody>
+          <a:bodyPr wrap="square" anchor="t">
+            <a:spAutoFit/>
+          </a:bodyPr>
+          <a:lstStyle/>
+          <a:p>
+            <a:pPr algn="l">
+              <a:lnSpc>
+                <a:spcPct val="100000"/>
+              </a:lnSpc>
+            </a:pPr>
+            <a:r>
+              <a:rPr sz="1200" b="1">
+                <a:solidFill>
+                  <a:srgbClr val="00FF41"/>
+                </a:solidFill>
+                <a:latin typeface="Courier New"/>
+              </a:rPr>
+              <a:t>MAKE IT REAL</a:t>
+            </a:r>
+          </a:p>
+        </p:txBody>
+      </p:sp>
+      <p:sp>
+        <p:nvSpPr>
+          <p:cNvPr id="8" name="TextBox 7"/>
+          <p:cNvSpPr txBox="1"/>
+          <p:nvPr/>
+        </p:nvSpPr>
+        <p:spPr>
+          <a:xfrm>
+            <a:off x="914400" y="3246120"/>
+            <a:ext cx="2844698" cy="822960"/>
+          </a:xfrm>
+          <a:prstGeom prst="rect">
+            <a:avLst/>
+          </a:prstGeom>
+          <a:noFill/>
+        </p:spPr>
+        <p:txBody>
+          <a:bodyPr wrap="square" anchor="t">
+            <a:spAutoFit/>
+          </a:bodyPr>
+          <a:lstStyle/>
+          <a:p>
+            <a:pPr algn="l">
+              <a:lnSpc>
+                <a:spcPct val="100000"/>
+              </a:lnSpc>
+            </a:pPr>
+            <a:r>
+              <a:rPr sz="2000" b="1">
+                <a:solidFill>
+                  <a:srgbClr val="F5F7FA"/>
+                </a:solidFill>
+                <a:latin typeface="Arial"/>
+              </a:rPr>
+              <a:t>AI builds it in minutes</a:t>
+            </a:r>
+          </a:p>
+        </p:txBody>
+      </p:sp>
+      <p:sp>
+        <p:nvSpPr>
+          <p:cNvPr id="9" name="TextBox 8"/>
+          <p:cNvSpPr txBox="1"/>
+          <p:nvPr/>
+        </p:nvSpPr>
+        <p:spPr>
+          <a:xfrm>
+            <a:off x="914400" y="4114800"/>
+            <a:ext cx="2844698" cy="1554480"/>
+          </a:xfrm>
+          <a:prstGeom prst="rect">
+            <a:avLst/>
+          </a:prstGeom>
+          <a:noFill/>
+        </p:spPr>
+        <p:txBody>
+          <a:bodyPr wrap="square" anchor="t">
+            <a:spAutoFit/>
+          </a:bodyPr>
+          <a:lstStyle/>
+          <a:p>
+            <a:pPr algn="l">
+              <a:lnSpc>
+                <a:spcPct val="110000"/>
+              </a:lnSpc>
+            </a:pPr>
+            <a:r>
+              <a:rPr sz="1500" b="0">
+                <a:solidFill>
+                  <a:srgbClr val="8A94A6"/>
+                </a:solidFill>
+                <a:latin typeface="Arial"/>
+              </a:rPr>
+              <a:t>Screens, button flows, one core interaction — if vibe coding gets it working fast, build it for real.</a:t>
+            </a:r>
+          </a:p>
+        </p:txBody>
+      </p:sp>
+      <p:sp>
+        <p:nvSpPr>
+          <p:cNvPr id="10" name="Rounded Rectangle 9"/>
+          <p:cNvSpPr/>
+          <p:nvPr/>
+        </p:nvSpPr>
+        <p:spPr>
+          <a:xfrm>
+            <a:off x="4399178" y="2468880"/>
+            <a:ext cx="3393338" cy="3383280"/>
+          </a:xfrm>
+          <a:prstGeom prst="roundRect">
+            <a:avLst/>
+          </a:prstGeom>
+          <a:solidFill>
+            <a:srgbClr val="151B26"/>
+          </a:solidFill>
+          <a:ln>
+            <a:noFill/>
+          </a:ln>
+          <a:effectLst/>
+        </p:spPr>
+        <p:style>
+          <a:lnRef idx="1">
+            <a:schemeClr val="accent1"/>
+          </a:lnRef>
+          <a:fillRef idx="3">
+            <a:schemeClr val="accent1"/>
+          </a:fillRef>
+          <a:effectRef idx="2">
+            <a:schemeClr val="accent1"/>
+          </a:effectRef>
+          <a:fontRef idx="minor">
+            <a:schemeClr val="lt1"/>
+          </a:fontRef>
+        </p:style>
+        <p:txBody>
+          <a:bodyPr rtlCol="0" anchor="ctr"/>
+          <a:lstStyle/>
+          <a:p>
+            <a:pPr algn="ctr"/>
+          </a:p>
+        </p:txBody>
+      </p:sp>
+      <p:sp>
+        <p:nvSpPr>
+          <p:cNvPr id="11" name="Rectangle 10"/>
+          <p:cNvSpPr/>
+          <p:nvPr/>
+        </p:nvSpPr>
+        <p:spPr>
+          <a:xfrm>
+            <a:off x="4399178" y="2468880"/>
+            <a:ext cx="3393338" cy="82296"/>
+          </a:xfrm>
+          <a:prstGeom prst="rect">
+            <a:avLst/>
+          </a:prstGeom>
+          <a:solidFill>
+            <a:srgbClr val="00FF41"/>
+          </a:solidFill>
+          <a:ln>
+            <a:noFill/>
+          </a:ln>
+          <a:effectLst/>
+        </p:spPr>
+        <p:style>
+          <a:lnRef idx="1">
+            <a:schemeClr val="accent1"/>
+          </a:lnRef>
+          <a:fillRef idx="3">
+            <a:schemeClr val="accent1"/>
+          </a:fillRef>
+          <a:effectRef idx="2">
+            <a:schemeClr val="accent1"/>
+          </a:effectRef>
+          <a:fontRef idx="minor">
+            <a:schemeClr val="lt1"/>
+          </a:fontRef>
+        </p:style>
+        <p:txBody>
+          <a:bodyPr rtlCol="0" anchor="ctr"/>
+          <a:lstStyle/>
+          <a:p>
+            <a:pPr algn="ctr"/>
+          </a:p>
+        </p:txBody>
+      </p:sp>
+      <p:sp>
+        <p:nvSpPr>
+          <p:cNvPr id="12" name="TextBox 11"/>
+          <p:cNvSpPr txBox="1"/>
+          <p:nvPr/>
+        </p:nvSpPr>
+        <p:spPr>
+          <a:xfrm>
+            <a:off x="4673498" y="2788920"/>
+            <a:ext cx="2844698" cy="457200"/>
+          </a:xfrm>
+          <a:prstGeom prst="rect">
+            <a:avLst/>
+          </a:prstGeom>
+          <a:noFill/>
+        </p:spPr>
+        <p:txBody>
+          <a:bodyPr wrap="square" anchor="t">
+            <a:spAutoFit/>
+          </a:bodyPr>
+          <a:lstStyle/>
+          <a:p>
+            <a:pPr algn="l">
+              <a:lnSpc>
+                <a:spcPct val="100000"/>
+              </a:lnSpc>
+            </a:pPr>
+            <a:r>
+              <a:rPr sz="1200" b="1">
+                <a:solidFill>
+                  <a:srgbClr val="00FF41"/>
+                </a:solidFill>
+                <a:latin typeface="Courier New"/>
+              </a:rPr>
+              <a:t>WIZARD IT</a:t>
+            </a:r>
+          </a:p>
+        </p:txBody>
+      </p:sp>
+      <p:sp>
+        <p:nvSpPr>
+          <p:cNvPr id="13" name="TextBox 12"/>
+          <p:cNvSpPr txBox="1"/>
+          <p:nvPr/>
+        </p:nvSpPr>
+        <p:spPr>
+          <a:xfrm>
+            <a:off x="4673498" y="3246120"/>
+            <a:ext cx="2844698" cy="822960"/>
+          </a:xfrm>
+          <a:prstGeom prst="rect">
+            <a:avLst/>
+          </a:prstGeom>
+          <a:noFill/>
+        </p:spPr>
+        <p:txBody>
+          <a:bodyPr wrap="square" anchor="t">
+            <a:spAutoFit/>
+          </a:bodyPr>
+          <a:lstStyle/>
+          <a:p>
+            <a:pPr algn="l">
+              <a:lnSpc>
+                <a:spcPct val="100000"/>
+              </a:lnSpc>
+            </a:pPr>
+            <a:r>
+              <a:rPr sz="2000" b="1">
+                <a:solidFill>
+                  <a:srgbClr val="F5F7FA"/>
+                </a:solidFill>
+                <a:latin typeface="Arial"/>
+              </a:rPr>
+              <a:t>A teammate plays it</a:t>
+            </a:r>
+          </a:p>
+        </p:txBody>
+      </p:sp>
+      <p:sp>
+        <p:nvSpPr>
+          <p:cNvPr id="14" name="TextBox 13"/>
+          <p:cNvSpPr txBox="1"/>
+          <p:nvPr/>
+        </p:nvSpPr>
+        <p:spPr>
+          <a:xfrm>
+            <a:off x="4673498" y="4114800"/>
+            <a:ext cx="2844698" cy="1554480"/>
+          </a:xfrm>
+          <a:prstGeom prst="rect">
+            <a:avLst/>
+          </a:prstGeom>
+          <a:noFill/>
+        </p:spPr>
+        <p:txBody>
+          <a:bodyPr wrap="square" anchor="t">
+            <a:spAutoFit/>
+          </a:bodyPr>
+          <a:lstStyle/>
+          <a:p>
+            <a:pPr algn="l">
+              <a:lnSpc>
+                <a:spcPct val="110000"/>
+              </a:lnSpc>
+            </a:pPr>
+            <a:r>
+              <a:rPr sz="1500" b="0">
+                <a:solidFill>
+                  <a:srgbClr val="8A94A6"/>
+                </a:solidFill>
+                <a:latin typeface="Arial"/>
+              </a:rPr>
+              <a:t>The recommendation 'algorithm', the notification, the other user — speak it, hand it over on a sticky note.</a:t>
+            </a:r>
+          </a:p>
+        </p:txBody>
+      </p:sp>
+      <p:sp>
+        <p:nvSpPr>
+          <p:cNvPr id="15" name="Rounded Rectangle 14"/>
+          <p:cNvSpPr/>
+          <p:nvPr/>
+        </p:nvSpPr>
+        <p:spPr>
+          <a:xfrm>
+            <a:off x="8158276" y="2468880"/>
+            <a:ext cx="3393338" cy="3383280"/>
+          </a:xfrm>
+          <a:prstGeom prst="roundRect">
+            <a:avLst/>
+          </a:prstGeom>
+          <a:solidFill>
+            <a:srgbClr val="151B26"/>
+          </a:solidFill>
+          <a:ln>
+            <a:noFill/>
+          </a:ln>
+          <a:effectLst/>
+        </p:spPr>
+        <p:style>
+          <a:lnRef idx="1">
+            <a:schemeClr val="accent1"/>
+          </a:lnRef>
+          <a:fillRef idx="3">
+            <a:schemeClr val="accent1"/>
+          </a:fillRef>
+          <a:effectRef idx="2">
+            <a:schemeClr val="accent1"/>
+          </a:effectRef>
+          <a:fontRef idx="minor">
+            <a:schemeClr val="lt1"/>
+          </a:fontRef>
+        </p:style>
+        <p:txBody>
+          <a:bodyPr rtlCol="0" anchor="ctr"/>
+          <a:lstStyle/>
+          <a:p>
+            <a:pPr algn="ctr"/>
+          </a:p>
+        </p:txBody>
+      </p:sp>
+      <p:sp>
+        <p:nvSpPr>
+          <p:cNvPr id="16" name="Rectangle 15"/>
+          <p:cNvSpPr/>
+          <p:nvPr/>
+        </p:nvSpPr>
+        <p:spPr>
+          <a:xfrm>
+            <a:off x="8158276" y="2468880"/>
+            <a:ext cx="3393338" cy="82296"/>
+          </a:xfrm>
+          <a:prstGeom prst="rect">
+            <a:avLst/>
+          </a:prstGeom>
+          <a:solidFill>
+            <a:srgbClr val="00FF41"/>
+          </a:solidFill>
+          <a:ln>
+            <a:noFill/>
+          </a:ln>
+          <a:effectLst/>
+        </p:spPr>
+        <p:style>
+          <a:lnRef idx="1">
+            <a:schemeClr val="accent1"/>
+          </a:lnRef>
+          <a:fillRef idx="3">
+            <a:schemeClr val="accent1"/>
+          </a:fillRef>
+          <a:effectRef idx="2">
+            <a:schemeClr val="accent1"/>
+          </a:effectRef>
+          <a:fontRef idx="minor">
+            <a:schemeClr val="lt1"/>
+          </a:fontRef>
+        </p:style>
+        <p:txBody>
+          <a:bodyPr rtlCol="0" anchor="ctr"/>
+          <a:lstStyle/>
+          <a:p>
+            <a:pPr algn="ctr"/>
+          </a:p>
+        </p:txBody>
+      </p:sp>
+      <p:sp>
+        <p:nvSpPr>
+          <p:cNvPr id="17" name="TextBox 16"/>
+          <p:cNvSpPr txBox="1"/>
+          <p:nvPr/>
+        </p:nvSpPr>
+        <p:spPr>
+          <a:xfrm>
+            <a:off x="8432596" y="2788920"/>
+            <a:ext cx="2844698" cy="457200"/>
+          </a:xfrm>
+          <a:prstGeom prst="rect">
+            <a:avLst/>
+          </a:prstGeom>
+          <a:noFill/>
+        </p:spPr>
+        <p:txBody>
+          <a:bodyPr wrap="square" anchor="t">
+            <a:spAutoFit/>
+          </a:bodyPr>
+          <a:lstStyle/>
+          <a:p>
+            <a:pPr algn="l">
+              <a:lnSpc>
+                <a:spcPct val="100000"/>
+              </a:lnSpc>
+            </a:pPr>
+            <a:r>
+              <a:rPr sz="1200" b="1">
+                <a:solidFill>
+                  <a:srgbClr val="00FF41"/>
+                </a:solidFill>
+                <a:latin typeface="Courier New"/>
+              </a:rPr>
+              <a:t>DON'T BUILD IT YET</a:t>
+            </a:r>
+          </a:p>
+        </p:txBody>
+      </p:sp>
+      <p:sp>
+        <p:nvSpPr>
+          <p:cNvPr id="18" name="TextBox 17"/>
+          <p:cNvSpPr txBox="1"/>
+          <p:nvPr/>
+        </p:nvSpPr>
+        <p:spPr>
+          <a:xfrm>
+            <a:off x="8432596" y="3246120"/>
+            <a:ext cx="2844698" cy="822960"/>
+          </a:xfrm>
+          <a:prstGeom prst="rect">
+            <a:avLst/>
+          </a:prstGeom>
+          <a:noFill/>
+        </p:spPr>
+        <p:txBody>
+          <a:bodyPr wrap="square" anchor="t">
+            <a:spAutoFit/>
+          </a:bodyPr>
+          <a:lstStyle/>
+          <a:p>
+            <a:pPr algn="l">
+              <a:lnSpc>
+                <a:spcPct val="100000"/>
+              </a:lnSpc>
+            </a:pPr>
+            <a:r>
+              <a:rPr sz="2000" b="1">
+                <a:solidFill>
+                  <a:srgbClr val="F5F7FA"/>
+                </a:solidFill>
+                <a:latin typeface="Arial"/>
+              </a:rPr>
+              <a:t>Stay imaginary</a:t>
+            </a:r>
+          </a:p>
+        </p:txBody>
+      </p:sp>
+      <p:sp>
+        <p:nvSpPr>
+          <p:cNvPr id="19" name="TextBox 18"/>
+          <p:cNvSpPr txBox="1"/>
+          <p:nvPr/>
+        </p:nvSpPr>
+        <p:spPr>
+          <a:xfrm>
+            <a:off x="8432596" y="4114800"/>
+            <a:ext cx="2844698" cy="1554480"/>
+          </a:xfrm>
+          <a:prstGeom prst="rect">
+            <a:avLst/>
+          </a:prstGeom>
+          <a:noFill/>
+        </p:spPr>
+        <p:txBody>
+          <a:bodyPr wrap="square" anchor="t">
+            <a:spAutoFit/>
+          </a:bodyPr>
+          <a:lstStyle/>
+          <a:p>
+            <a:pPr algn="l">
+              <a:lnSpc>
+                <a:spcPct val="110000"/>
+              </a:lnSpc>
+            </a:pPr>
+            <a:r>
+              <a:rPr sz="1500" b="0">
+                <a:solidFill>
+                  <a:srgbClr val="8A94A6"/>
+                </a:solidFill>
+                <a:latin typeface="Arial"/>
+              </a:rPr>
+              <a:t>Everything else waits. If the test says it doesn't matter, you never build it at all.</a:t>
+            </a:r>
+          </a:p>
+        </p:txBody>
+      </p:sp>
+      <p:sp>
+        <p:nvSpPr>
+          <p:cNvPr id="20" name="TextBox 19"/>
+          <p:cNvSpPr txBox="1"/>
+          <p:nvPr/>
+        </p:nvSpPr>
+        <p:spPr>
+          <a:xfrm>
+            <a:off x="640080" y="6355080"/>
+            <a:ext cx="10972800" cy="365760"/>
+          </a:xfrm>
+          <a:prstGeom prst="rect">
+            <a:avLst/>
+          </a:prstGeom>
+          <a:noFill/>
+        </p:spPr>
+        <p:txBody>
+          <a:bodyPr wrap="square" anchor="t">
+            <a:spAutoFit/>
+          </a:bodyPr>
+          <a:lstStyle/>
+          <a:p>
+            <a:pPr algn="l">
+              <a:lnSpc>
+                <a:spcPct val="100000"/>
+              </a:lnSpc>
+            </a:pPr>
+            <a:r>
+              <a:rPr sz="1000" b="0">
+                <a:solidFill>
+                  <a:srgbClr val="5A6474"/>
+                </a:solidFill>
+                <a:latin typeface="Courier New"/>
+              </a:rPr>
+              <a:t>Good Code, Good Vibes · TECHIE 1121 · Cornell Tech · Summer 2026</a:t>
+            </a:r>
+          </a:p>
+        </p:txBody>
+      </p:sp>
+    </p:spTree>
+  </p:cSld>
+  <p:clrMapOvr>
+    <a:masterClrMapping/>
+  </p:clrMapOvr>
+</p:sld>
+</file>
+
+<file path=ppt/slides/slide8.xml><?xml version="1.0" encoding="utf-8"?>
+<p:sld xmlns:a="http://schemas.openxmlformats.org/drawingml/2006/main" xmlns:p="http://schemas.openxmlformats.org/presentationml/2006/main" xmlns:r="http://schemas.openxmlformats.org/officeDocument/2006/relationships">
+  <p:cSld>
+    <p:bg>
+      <p:bgPr>
+        <a:solidFill>
+          <a:srgbClr val="0B0E14"/>
+        </a:solidFill>
+        <a:effectLst/>
+      </p:bgPr>
+    </p:bg>
+    <p:spTree>
+      <p:nvGrpSpPr>
+        <p:cNvPr id="1" name=""/>
+        <p:cNvGrpSpPr/>
+        <p:nvPr/>
+      </p:nvGrpSpPr>
+      <p:grpSpPr/>
+      <p:sp>
+        <p:nvSpPr>
+          <p:cNvPr id="2" name="TextBox 1"/>
+          <p:cNvSpPr txBox="1"/>
+          <p:nvPr/>
+        </p:nvSpPr>
+        <p:spPr>
+          <a:xfrm>
+            <a:off x="640080" y="502920"/>
+            <a:ext cx="10058400" cy="365760"/>
+          </a:xfrm>
+          <a:prstGeom prst="rect">
+            <a:avLst/>
+          </a:prstGeom>
+          <a:noFill/>
+        </p:spPr>
+        <p:txBody>
+          <a:bodyPr wrap="square" anchor="t">
+            <a:spAutoFit/>
+          </a:bodyPr>
+          <a:lstStyle/>
+          <a:p>
+            <a:pPr algn="l">
+              <a:lnSpc>
+                <a:spcPct val="100000"/>
+              </a:lnSpc>
+            </a:pPr>
+            <a:r>
+              <a:rPr sz="1300" b="1">
+                <a:solidFill>
+                  <a:srgbClr val="00FF41"/>
+                </a:solidFill>
+                <a:latin typeface="Courier New"/>
+              </a:rPr>
+              <a:t>RESEARCH</a:t>
+            </a:r>
+          </a:p>
+        </p:txBody>
+      </p:sp>
+      <p:sp>
+        <p:nvSpPr>
+          <p:cNvPr id="3" name="Rectangle 2"/>
+          <p:cNvSpPr/>
+          <p:nvPr/>
+        </p:nvSpPr>
+        <p:spPr>
+          <a:xfrm>
+            <a:off x="640080" y="932688"/>
+            <a:ext cx="822960" cy="73152"/>
+          </a:xfrm>
+          <a:prstGeom prst="rect">
+            <a:avLst/>
+          </a:prstGeom>
+          <a:solidFill>
+            <a:srgbClr val="00FF41"/>
+          </a:solidFill>
+          <a:ln>
+            <a:noFill/>
+          </a:ln>
+          <a:effectLst/>
+        </p:spPr>
+        <p:style>
+          <a:lnRef idx="1">
+            <a:schemeClr val="accent1"/>
+          </a:lnRef>
+          <a:fillRef idx="3">
+            <a:schemeClr val="accent1"/>
+          </a:fillRef>
+          <a:effectRef idx="2">
+            <a:schemeClr val="accent1"/>
+          </a:effectRef>
+          <a:fontRef idx="minor">
+            <a:schemeClr val="lt1"/>
+          </a:fontRef>
+        </p:style>
+        <p:txBody>
+          <a:bodyPr rtlCol="0" anchor="ctr"/>
+          <a:lstStyle/>
+          <a:p>
+            <a:pPr algn="ctr"/>
+          </a:p>
+        </p:txBody>
+      </p:sp>
+      <p:sp>
+        <p:nvSpPr>
+          <p:cNvPr id="4" name="TextBox 3"/>
+          <p:cNvSpPr txBox="1"/>
+          <p:nvPr/>
+        </p:nvSpPr>
+        <p:spPr>
+          <a:xfrm>
+            <a:off x="640080" y="1188720"/>
+            <a:ext cx="10972800" cy="1097280"/>
+          </a:xfrm>
+          <a:prstGeom prst="rect">
+            <a:avLst/>
+          </a:prstGeom>
+          <a:noFill/>
+        </p:spPr>
+        <p:txBody>
+          <a:bodyPr wrap="square" anchor="t">
+            <a:spAutoFit/>
+          </a:bodyPr>
+          <a:lstStyle/>
+          <a:p>
+            <a:pPr algn="l">
+              <a:lnSpc>
+                <a:spcPct val="100000"/>
+              </a:lnSpc>
+            </a:pPr>
+            <a:r>
+              <a:rPr sz="3400" b="1">
+                <a:solidFill>
+                  <a:srgbClr val="F5F7FA"/>
+                </a:solidFill>
+                <a:latin typeface="Arial"/>
+              </a:rPr>
+              <a:t>Co-designing with AI — what we learned</a:t>
+            </a:r>
+          </a:p>
+        </p:txBody>
+      </p:sp>
+      <p:sp>
+        <p:nvSpPr>
+          <p:cNvPr id="5" name="TextBox 4"/>
+          <p:cNvSpPr txBox="1"/>
+          <p:nvPr/>
+        </p:nvSpPr>
+        <p:spPr>
+          <a:xfrm>
+            <a:off x="658368" y="2286000"/>
+            <a:ext cx="10881360" cy="3657600"/>
+          </a:xfrm>
+          <a:prstGeom prst="rect">
+            <a:avLst/>
+          </a:prstGeom>
+          <a:noFill/>
+        </p:spPr>
+        <p:txBody>
+          <a:bodyPr wrap="square" anchor="t">
+            <a:spAutoFit/>
+          </a:bodyPr>
+          <a:lstStyle/>
+          <a:p>
+            <a:pPr algn="l">
+              <a:lnSpc>
+                <a:spcPct val="112000"/>
+              </a:lnSpc>
+            </a:pPr>
+            <a:r>
+              <a:rPr sz="2000" b="0">
+                <a:solidFill>
+                  <a:srgbClr val="F5F7FA"/>
+                </a:solidFill>
+                <a:latin typeface="Arial"/>
+              </a:rPr>
+              <a:t>Sandhaus, Gu, Parreira &amp; Ju, DIS '25 — your instructor's own research on GenAI in interactive-device design education.</a:t>
+            </a:r>
+          </a:p>
+          <a:p>
+            <a:pPr algn="l">
+              <a:lnSpc>
+                <a:spcPct val="112000"/>
+              </a:lnSpc>
+            </a:pPr>
+            <a:r>
+              <a:rPr sz="2000" b="0">
+                <a:solidFill>
+                  <a:srgbClr val="F5F7FA"/>
+                </a:solidFill>
+                <a:latin typeface="Arial"/>
+              </a:rPr>
+              <a:t>When transformers compress the build step, design iterations accelerate: students got through more design loops in the same time — more chances to catch the wrong thing early.</a:t>
+            </a:r>
+          </a:p>
+          <a:p>
+            <a:pPr algn="l">
+              <a:lnSpc>
+                <a:spcPct val="112000"/>
+              </a:lnSpc>
+            </a:pPr>
+            <a:r>
+              <a:rPr sz="2000" b="0">
+                <a:solidFill>
+                  <a:srgbClr val="F5F7FA"/>
+                </a:solidFill>
+                <a:latin typeface="Arial"/>
+              </a:rPr>
+              <a:t>But the role of GenAI is complex: accept its defaults passively and it can flatten your exploration instead of widening it.</a:t>
+            </a:r>
+          </a:p>
+          <a:p>
+            <a:pPr algn="l">
+              <a:lnSpc>
+                <a:spcPct val="112000"/>
+              </a:lnSpc>
+            </a:pPr>
+            <a:r>
+              <a:rPr sz="2000" b="0">
+                <a:solidFill>
+                  <a:srgbClr val="F5F7FA"/>
+                </a:solidFill>
+                <a:latin typeface="Arial"/>
+              </a:rPr>
+              <a:t>So treat the AI as a design COLLABORATOR — push back, ask it for alternatives, make it argue — not as a vending machine for code.</a:t>
+            </a:r>
+          </a:p>
+        </p:txBody>
+      </p:sp>
+      <p:sp>
+        <p:nvSpPr>
+          <p:cNvPr id="6" name="TextBox 5"/>
+          <p:cNvSpPr txBox="1"/>
+          <p:nvPr/>
+        </p:nvSpPr>
+        <p:spPr>
+          <a:xfrm>
+            <a:off x="640080" y="6355080"/>
+            <a:ext cx="10972800" cy="365760"/>
+          </a:xfrm>
+          <a:prstGeom prst="rect">
+            <a:avLst/>
+          </a:prstGeom>
+          <a:noFill/>
+        </p:spPr>
+        <p:txBody>
+          <a:bodyPr wrap="square" anchor="t">
+            <a:spAutoFit/>
+          </a:bodyPr>
+          <a:lstStyle/>
+          <a:p>
+            <a:pPr algn="l">
+              <a:lnSpc>
+                <a:spcPct val="100000"/>
+              </a:lnSpc>
+            </a:pPr>
+            <a:r>
+              <a:rPr sz="1000" b="0">
+                <a:solidFill>
+                  <a:srgbClr val="5A6474"/>
+                </a:solidFill>
+                <a:latin typeface="Courier New"/>
+              </a:rPr>
+              <a:t>Good Code, Good Vibes · TECHIE 1121 · Cornell Tech · Summer 2026</a:t>
+            </a:r>
+          </a:p>
+        </p:txBody>
+      </p:sp>
+    </p:spTree>
+  </p:cSld>
+  <p:clrMapOvr>
+    <a:masterClrMapping/>
+  </p:clrMapOvr>
+</p:sld>
+</file>
+
+<file path=ppt/slides/slide9.xml><?xml version="1.0" encoding="utf-8"?>
+<p:sld xmlns:a="http://schemas.openxmlformats.org/drawingml/2006/main" xmlns:p="http://schemas.openxmlformats.org/presentationml/2006/main" xmlns:r="http://schemas.openxmlformats.org/officeDocument/2006/relationships">
+  <p:cSld>
+    <p:bg>
+      <p:bgPr>
+        <a:solidFill>
+          <a:srgbClr val="0B0E14"/>
+        </a:solidFill>
+        <a:effectLst/>
+      </p:bgPr>
+    </p:bg>
+    <p:spTree>
+      <p:nvGrpSpPr>
+        <p:cNvPr id="1" name=""/>
+        <p:cNvGrpSpPr/>
+        <p:nvPr/>
+      </p:nvGrpSpPr>
+      <p:grpSpPr/>
+      <p:sp>
+        <p:nvSpPr>
+          <p:cNvPr id="2" name="TextBox 1"/>
+          <p:cNvSpPr txBox="1"/>
+          <p:nvPr/>
+        </p:nvSpPr>
+        <p:spPr>
+          <a:xfrm>
+            <a:off x="640080" y="502920"/>
+            <a:ext cx="10058400" cy="365760"/>
+          </a:xfrm>
+          <a:prstGeom prst="rect">
+            <a:avLst/>
+          </a:prstGeom>
+          <a:noFill/>
+        </p:spPr>
+        <p:txBody>
+          <a:bodyPr wrap="square" anchor="t">
+            <a:spAutoFit/>
+          </a:bodyPr>
+          <a:lstStyle/>
+          <a:p>
+            <a:pPr algn="l">
+              <a:lnSpc>
+                <a:spcPct val="100000"/>
+              </a:lnSpc>
+            </a:pPr>
+            <a:r>
+              <a:rPr sz="1300" b="1">
+                <a:solidFill>
+                  <a:srgbClr val="00FF41"/>
+                </a:solidFill>
+                <a:latin typeface="Courier New"/>
+              </a:rPr>
+              <a:t>TODAY</a:t>
+            </a:r>
+          </a:p>
+        </p:txBody>
+      </p:sp>
+      <p:sp>
+        <p:nvSpPr>
+          <p:cNvPr id="3" name="Rectangle 2"/>
+          <p:cNvSpPr/>
+          <p:nvPr/>
+        </p:nvSpPr>
+        <p:spPr>
+          <a:xfrm>
+            <a:off x="640080" y="932688"/>
+            <a:ext cx="822960" cy="73152"/>
+          </a:xfrm>
+          <a:prstGeom prst="rect">
+            <a:avLst/>
+          </a:prstGeom>
+          <a:solidFill>
+            <a:srgbClr val="00FF41"/>
+          </a:solidFill>
+          <a:ln>
+            <a:noFill/>
+          </a:ln>
+          <a:effectLst/>
+        </p:spPr>
+        <p:style>
+          <a:lnRef idx="1">
+            <a:schemeClr val="accent1"/>
+          </a:lnRef>
+          <a:fillRef idx="3">
+            <a:schemeClr val="accent1"/>
+          </a:fillRef>
+          <a:effectRef idx="2">
+            <a:schemeClr val="accent1"/>
+          </a:effectRef>
+          <a:fontRef idx="minor">
+            <a:schemeClr val="lt1"/>
+          </a:fontRef>
+        </p:style>
+        <p:txBody>
+          <a:bodyPr rtlCol="0" anchor="ctr"/>
+          <a:lstStyle/>
+          <a:p>
+            <a:pPr algn="ctr"/>
+          </a:p>
+        </p:txBody>
+      </p:sp>
+      <p:sp>
+        <p:nvSpPr>
+          <p:cNvPr id="4" name="TextBox 3"/>
+          <p:cNvSpPr txBox="1"/>
+          <p:nvPr/>
+        </p:nvSpPr>
+        <p:spPr>
+          <a:xfrm>
+            <a:off x="640080" y="1188720"/>
+            <a:ext cx="10972800" cy="914400"/>
+          </a:xfrm>
+          <a:prstGeom prst="rect">
+            <a:avLst/>
+          </a:prstGeom>
+          <a:noFill/>
+        </p:spPr>
+        <p:txBody>
+          <a:bodyPr wrap="square" anchor="t">
+            <a:spAutoFit/>
+          </a:bodyPr>
+          <a:lstStyle/>
+          <a:p>
+            <a:pPr algn="l">
+              <a:lnSpc>
+                <a:spcPct val="100000"/>
+              </a:lnSpc>
+            </a:pPr>
+            <a:r>
+              <a:rPr sz="3400" b="1">
+                <a:solidFill>
+                  <a:srgbClr val="F5F7FA"/>
+                </a:solidFill>
+                <a:latin typeface="Arial"/>
+              </a:rPr>
+              <a:t>The method — one loop, then build</a:t>
+            </a:r>
+          </a:p>
+        </p:txBody>
+      </p:sp>
+      <p:sp>
+        <p:nvSpPr>
+          <p:cNvPr id="5" name="TextBox 4"/>
+          <p:cNvSpPr txBox="1"/>
+          <p:nvPr/>
+        </p:nvSpPr>
+        <p:spPr>
+          <a:xfrm>
+            <a:off x="822960" y="2286000"/>
+            <a:ext cx="10515600" cy="3840480"/>
+          </a:xfrm>
+          <a:prstGeom prst="rect">
+            <a:avLst/>
+          </a:prstGeom>
+          <a:noFill/>
+        </p:spPr>
+        <p:txBody>
+          <a:bodyPr wrap="square" anchor="t">
+            <a:spAutoFit/>
+          </a:bodyPr>
+          <a:lstStyle/>
+          <a:p>
+            <a:pPr algn="l">
+              <a:lnSpc>
+                <a:spcPct val="135000"/>
+              </a:lnSpc>
+            </a:pPr>
+            <a:r>
+              <a:rPr sz="2000" b="1">
+                <a:solidFill>
+                  <a:srgbClr val="00FF41"/>
+                </a:solidFill>
+                <a:latin typeface="Arial"/>
+              </a:rPr>
+              <a:t>✓  </a:t>
+            </a:r>
+            <a:r>
+              <a:rPr sz="2000" b="0">
+                <a:solidFill>
+                  <a:srgbClr val="F5F7FA"/>
+                </a:solidFill>
+                <a:latin typeface="Arial"/>
+              </a:rPr>
+              <a:t>DIVERGE — brainstorm problems fast, pick one that's genuinely yours.</a:t>
+            </a:r>
+          </a:p>
+          <a:p>
+            <a:pPr algn="l">
+              <a:lnSpc>
+                <a:spcPct val="135000"/>
+              </a:lnSpc>
+            </a:pPr>
+            <a:r>
+              <a:rPr sz="2000" b="1">
+                <a:solidFill>
+                  <a:srgbClr val="00FF41"/>
+                </a:solidFill>
+                <a:latin typeface="Arial"/>
+              </a:rPr>
+              <a:t>✓  </a:t>
+            </a:r>
+            <a:r>
+              <a:rPr sz="2000" b="0">
+                <a:solidFill>
+                  <a:srgbClr val="F5F7FA"/>
+                </a:solidFill>
+                <a:latin typeface="Arial"/>
+              </a:rPr>
+              <a:t>FAKE IT (in class) — AI-build the quick parts, wizard the rest, test ONCE with a teammate or neighboring team.</a:t>
+            </a:r>
+          </a:p>
+          <a:p>
+            <a:pPr algn="l">
+              <a:lnSpc>
+                <a:spcPct val="135000"/>
+              </a:lnSpc>
+            </a:pPr>
+            <a:r>
+              <a:rPr sz="2000" b="1">
+                <a:solidFill>
+                  <a:srgbClr val="00FF41"/>
+                </a:solidFill>
+                <a:latin typeface="Arial"/>
+              </a:rPr>
+              <a:t>✓  </a:t>
+            </a:r>
+            <a:r>
+              <a:rPr sz="2000" b="0">
+                <a:solidFill>
+                  <a:srgbClr val="F5F7FA"/>
+                </a:solidFill>
+                <a:latin typeface="Arial"/>
+              </a:rPr>
+              <a:t>CONVERGE — are we making the right thing? Redefine the problem, re-scope the build.</a:t>
+            </a:r>
+          </a:p>
+          <a:p>
+            <a:pPr algn="l">
+              <a:lnSpc>
+                <a:spcPct val="135000"/>
+              </a:lnSpc>
+            </a:pPr>
+            <a:r>
+              <a:rPr sz="2000" b="1">
+                <a:solidFill>
+                  <a:srgbClr val="00FF41"/>
+                </a:solidFill>
+                <a:latin typeface="Arial"/>
+              </a:rPr>
+              <a:t>✓  </a:t>
+            </a:r>
+            <a:r>
+              <a:rPr sz="2000" b="0">
+                <a:solidFill>
+                  <a:srgbClr val="F5F7FA"/>
+                </a:solidFill>
+                <a:latin typeface="Arial"/>
+              </a:rPr>
+              <a:t>BUILD FOCUSED — co-design the re-scoped app with the AI. No re-test required — deep user testing comes in Weeks 2–3.</a:t>
             </a:r>
           </a:p>
         </p:txBody>

</xml_diff>